<commit_message>
docs(apresentacoes): adapta os slides para estudar o RAP no BTP ou On-Premise
Os cinco decks passam a ensinar a mesma aplicação para quem estuda no
SAP BTP, ABAP environment ou num SAP S/4HANA On-Premise:

- capas e rodapés sem o foco exclusivo no SAP BTP;
- etapa 1: novo slide "O mesmo RAP no SAP BTP ou no SAP On-Premise"
  (código único, versão de linguagem, ferramentas, os dois objetos que
  mudam, autorização e launchpad) e pilha tecnológica neutra;
- etapa 2: notas lembram que as views CDS são idênticas;
- etapa 3: novo slide com ZCL_PC_VIACEP no On-Premise (CL_HTTP_CLIENT,
  destination SM59 e STRUST, pacote Standard ABAP sem contrato C1);
- etapas 4 e 5: slides de IAM, Publish e deploy marcados como SAP BTP,
  textos de proxy e encerramento neutros e caminho de diagramas/.

Co-Authored-By: Claude Opus 5.5 <noreply@anthropic.com>
</commit_message>
<xml_diff>
--- a/docs/apresentacoes/04-servicos-odata.pptx
+++ b/docs/apresentacoes/04-servicos-odata.pptx
@@ -2936,7 +2936,7 @@
                   <a:srgbClr val="556B82"/>
                 </a:solidFill>
               </a:rPr>
-              <a:t>Pedidos de Compras · SAP RAP / ABAP Cloud  ·  Etapa 4 de 5 — Serviços OData</a:t>
+              <a:t>Pedidos de Compras · SAP RAP no BTP e On-Premise  ·  Etapa 4 de 5 — Serviços OData</a:t>
             </a:r>
             <a:endParaRPr lang="en-US" sz="900" dirty="0"/>
           </a:p>
@@ -3525,7 +3525,7 @@
                   <a:schemeClr val="accent1"/>
                 </a:solidFill>
               </a:rPr>
-              <a:t>ETAPA 4 DE 5 · PEDIDOS DE COMPRAS NO SAP BTP</a:t>
+              <a:t>ETAPA 4 DE 5 · SAP RAP NO BTP OU ON-PREMISE</a:t>
             </a:r>
             <a:endParaRPr lang="en-US" sz="1400" dirty="0"/>
           </a:p>
@@ -3601,7 +3601,7 @@
                   <a:schemeClr val="bg2"/>
                 </a:solidFill>
               </a:rPr>
-              <a:t>Expor cada BO como serviço OData V4, publicar os bindings e liberar o acesso com IAM Apps, catálogos e roles</a:t>
+              <a:t>Expor cada BO como serviço OData V4, publicar os bindings e liberar o acesso: IAM Apps no BTP, SU24 e PFCG no On-Premise</a:t>
             </a:r>
             <a:endParaRPr lang="en-US" sz="1800" dirty="0"/>
           </a:p>
@@ -4121,7 +4121,7 @@
                   <a:schemeClr val="accent1"/>
                 </a:solidFill>
               </a:rPr>
-              <a:t>COMMON · IAM POR DOMÍNIO</a:t>
+              <a:t>COMMON · IAM POR DOMÍNIO (SAP BTP)</a:t>
             </a:r>
             <a:endParaRPr lang="en-US" sz="1100" dirty="0"/>
           </a:p>
@@ -25584,7 +25584,7 @@
                   <a:schemeClr val="bg2"/>
                 </a:solidFill>
               </a:rPr>
-              <a:t>Cinco serviços OData V4, BDEFs de projeção, objetos de autorização, IAM Apps, catálogos, roles e dados de demonstração.</a:t>
+              <a:t>Cinco serviços OData V4, BDEFs de projeção, objetos de autorização, IAM Apps (BTP) ou roles PFCG (On-Premise) e dados de demonstração.</a:t>
             </a:r>
             <a:endParaRPr lang="en-US" sz="1800" dirty="0"/>
           </a:p>
@@ -32804,7 +32804,7 @@
                   <a:schemeClr val="accent1"/>
                 </a:solidFill>
               </a:rPr>
-              <a:t>PUBLICAÇÃO</a:t>
+              <a:t>PUBLICAÇÃO · SAP BTP</a:t>
             </a:r>
             <a:endParaRPr lang="en-US" sz="1100" dirty="0"/>
           </a:p>
@@ -32842,7 +32842,7 @@
                   <a:schemeClr val="tx1"/>
                 </a:solidFill>
               </a:rPr>
-              <a:t>O que o Publish cria por trás</a:t>
+              <a:t>O que o Publish cria por trás no SAP BTP</a:t>
             </a:r>
             <a:endParaRPr lang="en-US" sz="3000" dirty="0"/>
           </a:p>
@@ -33602,7 +33602,7 @@
                   <a:schemeClr val="bg2"/>
                 </a:solidFill>
               </a:rPr>
-              <a:t>Os dois objetos de autorização, a cadeia de IAM que libera os serviços aos usuários e o serviço analítico compartilhado pelas quatro apps de análise.</a:t>
+              <a:t>Os dois objetos de autorização, a cadeia de IAM que libera os serviços no SAP BTP e o serviço analítico compartilhado pelas quatro apps de análise.</a:t>
             </a:r>
             <a:endParaRPr lang="en-US" sz="1800" dirty="0"/>
           </a:p>
@@ -35967,7 +35967,7 @@
                   <a:schemeClr val="accent1"/>
                 </a:solidFill>
               </a:rPr>
-              <a:t>COMMON · IAM</a:t>
+              <a:t>COMMON · IAM (SAP BTP)</a:t>
             </a:r>
             <a:endParaRPr lang="en-US" sz="1100" dirty="0"/>
           </a:p>
@@ -36005,7 +36005,7 @@
                   <a:schemeClr val="tx1"/>
                 </a:solidFill>
               </a:rPr>
-              <a:t>Do objeto de autorização ao usuário</a:t>
+              <a:t>Do objeto de autorização ao usuário no SAP BTP</a:t>
             </a:r>
             <a:endParaRPr lang="en-US" sz="3000" dirty="0"/>
           </a:p>

</xml_diff>

<commit_message>
docs(apresentacoes): azul do projeto CAP, capa e resumo da etapa
Troca o modo escuro (12171C) pelo azul-marinho das apresentações do
projeto CAP (00144A), com painéis em 1B3A7A e destaques em 89D1FF, e
segue o mesmo desenho de abertura e encerramento:

- capa de cada etapa com "ETAPA 0N DE 05", ícone da etapa em quadrado
  arredondado, barra de progresso de cinco segmentos e rodapé;
- encerramento "Resumo da etapa" com seis entregas marcadas e a faixa
  "Próxima etapa" (na etapa 5, "Série concluída");
- divisores de seção e "A série completa" no mesmo azul, sem os
  círculos decorativos.

Co-Authored-By: Claude Opus 5.5 <noreply@anthropic.com>
</commit_message>
<xml_diff>
--- a/docs/apresentacoes/04-servicos-odata.pptx
+++ b/docs/apresentacoes/04-servicos-odata.pptx
@@ -3046,7 +3046,7 @@
     <p:bg>
       <p:bgPr>
         <a:solidFill>
-          <a:srgbClr val="12171C"/>
+          <a:srgbClr val="00144A"/>
         </a:solidFill>
       </p:bgPr>
     </p:bg>
@@ -3195,7 +3195,7 @@
     <p:bg>
       <p:bgPr>
         <a:solidFill>
-          <a:srgbClr val="12171C"/>
+          <a:srgbClr val="00144A"/>
         </a:solidFill>
       </p:bgPr>
     </p:bg>
@@ -3535,7 +3535,7 @@
     <p:bg>
       <p:bgPr>
         <a:solidFill>
-          <a:srgbClr val="12171C"/>
+          <a:srgbClr val="00144A"/>
         </a:solidFill>
       </p:bgPr>
     </p:bg>
@@ -4037,8 +4037,8 @@
         </p:nvSpPr>
         <p:spPr>
           <a:xfrm>
-            <a:off x="731520" y="1325880"/>
-            <a:ext cx="7772400" cy="365760"/>
+            <a:off x="731520" y="1417320"/>
+            <a:ext cx="5486400" cy="411480"/>
           </a:xfrm>
           <a:prstGeom prst="rect">
             <a:avLst/>
@@ -4056,10 +4056,10 @@
             <a:r>
               <a:rPr lang="en-US" sz="1400" b="1" spc="200" kern="0" dirty="0">
                 <a:solidFill>
-                  <a:schemeClr val="accent1"/>
-                </a:solidFill>
-              </a:rPr>
-              <a:t>ETAPA 4 DE 5 · SAP RAP NO BTP OU ON-PREMISE</a:t>
+                  <a:srgbClr val="89D1FF"/>
+                </a:solidFill>
+              </a:rPr>
+              <a:t>ETAPA 04 DE 05</a:t>
             </a:r>
             <a:endParaRPr lang="en-US" sz="1400" dirty="0"/>
           </a:p>
@@ -4075,8 +4075,8 @@
         </p:nvSpPr>
         <p:spPr>
           <a:xfrm>
-            <a:off x="731520" y="1737360"/>
-            <a:ext cx="7680960" cy="1600200"/>
+            <a:off x="731520" y="1965960"/>
+            <a:ext cx="6766560" cy="1737360"/>
           </a:xfrm>
           <a:prstGeom prst="rect">
             <a:avLst/>
@@ -4092,14 +4092,14 @@
               <a:buNone/>
             </a:pPr>
             <a:r>
-              <a:rPr lang="en-US" sz="4800" b="1" dirty="0">
+              <a:rPr lang="en-US" sz="4400" b="1" dirty="0">
                 <a:solidFill>
                   <a:schemeClr val="bg1"/>
                 </a:solidFill>
               </a:rPr>
               <a:t>Serviços OData</a:t>
             </a:r>
-            <a:endParaRPr lang="en-US" sz="4800" dirty="0"/>
+            <a:endParaRPr lang="en-US" sz="4400" dirty="0"/>
           </a:p>
         </p:txBody>
       </p:sp>
@@ -4113,8 +4113,8 @@
         </p:nvSpPr>
         <p:spPr>
           <a:xfrm>
-            <a:off x="731520" y="3383280"/>
-            <a:ext cx="7132320" cy="914400"/>
+            <a:off x="731520" y="3840480"/>
+            <a:ext cx="6400800" cy="1097280"/>
           </a:xfrm>
           <a:prstGeom prst="rect">
             <a:avLst/>
@@ -4132,7 +4132,7 @@
             <a:r>
               <a:rPr lang="en-US" sz="1800" dirty="0">
                 <a:solidFill>
-                  <a:schemeClr val="bg2"/>
+                  <a:srgbClr val="D1EFFF"/>
                 </a:solidFill>
               </a:rPr>
               <a:t>Expor cada BO como serviço OData V4, publicar os bindings e liberar o acesso: IAM Apps no BTP, SU24 e PFCG no On-Premise</a:t>
@@ -4143,71 +4143,72 @@
       </p:sp>
       <p:sp>
         <p:nvSpPr>
-          <p:cNvPr id="5" name="Decoração 1"/>
+          <p:cNvPr id="5" name="Avatar da etapa"/>
           <p:cNvSpPr/>
           <p:nvPr/>
         </p:nvSpPr>
         <p:spPr>
           <a:xfrm>
-            <a:off x="8503920" y="-1463040"/>
-            <a:ext cx="5120640" cy="5120640"/>
-          </a:xfrm>
-          <a:prstGeom prst="ellipse">
+            <a:off x="8183880" y="1417320"/>
+            <a:ext cx="3291840" cy="3291840"/>
+          </a:xfrm>
+          <a:prstGeom prst="roundRect">
+            <a:avLst>
+              <a:gd name="adj" fmla="val 22222"/>
+            </a:avLst>
+          </a:prstGeom>
+          <a:solidFill>
+            <a:srgbClr val="1B3A7A"/>
+          </a:solidFill>
+          <a:ln/>
+        </p:spPr>
+      </p:sp>
+      <p:sp>
+        <p:nvSpPr>
+          <p:cNvPr id="6" name="Avatar interno"/>
+          <p:cNvSpPr/>
+          <p:nvPr/>
+        </p:nvSpPr>
+        <p:spPr>
+          <a:xfrm>
+            <a:off x="8732520" y="1965960"/>
+            <a:ext cx="2194560" cy="2194560"/>
+          </a:xfrm>
+          <a:prstGeom prst="roundRect">
+            <a:avLst>
+              <a:gd name="adj" fmla="val 22917"/>
+            </a:avLst>
+          </a:prstGeom>
+          <a:solidFill>
+            <a:schemeClr val="accent1"/>
+          </a:solidFill>
+          <a:ln/>
+        </p:spPr>
+      </p:sp>
+      <p:pic>
+        <p:nvPicPr>
+          <p:cNvPr id="7" name="Image 0" descr="Serviços OData">    </p:cNvPr>
+          <p:cNvPicPr>
+            <a:picLocks noChangeAspect="1"/>
+          </p:cNvPicPr>
+          <p:nvPr/>
+        </p:nvPicPr>
+        <p:blipFill>
+          <a:blip r:embed="rId100"/>
+          <a:stretch>
+            <a:fillRect/>
+          </a:stretch>
+        </p:blipFill>
+        <p:spPr>
+          <a:xfrm>
+            <a:off x="9281160" y="2514600"/>
+            <a:ext cx="1097280" cy="1097280"/>
+          </a:xfrm>
+          <a:prstGeom prst="rect">
             <a:avLst/>
           </a:prstGeom>
-          <a:solidFill>
-            <a:srgbClr val="0070F2">
-              <a:alpha val="28000"/>
-            </a:srgbClr>
-          </a:solidFill>
-          <a:ln/>
-        </p:spPr>
-      </p:sp>
-      <p:sp>
-        <p:nvSpPr>
-          <p:cNvPr id="6" name="Decoração 2"/>
-          <p:cNvSpPr/>
-          <p:nvPr/>
-        </p:nvSpPr>
-        <p:spPr>
-          <a:xfrm>
-            <a:off x="9784080" y="1828800"/>
-            <a:ext cx="2834640" cy="2834640"/>
-          </a:xfrm>
-          <a:prstGeom prst="ellipse">
-            <a:avLst/>
-          </a:prstGeom>
-          <a:solidFill>
-            <a:srgbClr val="4DB1FF">
-              <a:alpha val="18000"/>
-            </a:srgbClr>
-          </a:solidFill>
-          <a:ln/>
-        </p:spPr>
-      </p:sp>
-      <p:sp>
-        <p:nvSpPr>
-          <p:cNvPr id="7" name="Shape 5"/>
-          <p:cNvSpPr/>
-          <p:nvPr/>
-        </p:nvSpPr>
-        <p:spPr>
-          <a:xfrm>
-            <a:off x="923544" y="5266944"/>
-            <a:ext cx="10131552" cy="0"/>
-          </a:xfrm>
-          <a:prstGeom prst="line">
-            <a:avLst/>
-          </a:prstGeom>
-          <a:noFill/>
-          <a:ln w="25400">
-            <a:solidFill>
-              <a:srgbClr val="3A4654"/>
-            </a:solidFill>
-            <a:prstDash val="solid"/>
-          </a:ln>
-        </p:spPr>
-      </p:sp>
+        </p:spPr>
+      </p:pic>
       <p:sp>
         <p:nvSpPr>
           <p:cNvPr id="8" name="Etapa 1"/>
@@ -4216,385 +4217,172 @@
         </p:nvSpPr>
         <p:spPr>
           <a:xfrm>
-            <a:off x="731520" y="5074920"/>
-            <a:ext cx="384048" cy="384048"/>
-          </a:xfrm>
-          <a:prstGeom prst="ellipse">
+            <a:off x="8183880" y="5074920"/>
+            <a:ext cx="570586" cy="109728"/>
+          </a:xfrm>
+          <a:prstGeom prst="roundRect">
+            <a:avLst>
+              <a:gd name="adj" fmla="val 50000"/>
+            </a:avLst>
+          </a:prstGeom>
+          <a:solidFill>
+            <a:srgbClr val="1B3A7A"/>
+          </a:solidFill>
+          <a:ln/>
+        </p:spPr>
+      </p:sp>
+      <p:sp>
+        <p:nvSpPr>
+          <p:cNvPr id="9" name="Etapa 2"/>
+          <p:cNvSpPr/>
+          <p:nvPr/>
+        </p:nvSpPr>
+        <p:spPr>
+          <a:xfrm>
+            <a:off x="8864194" y="5074920"/>
+            <a:ext cx="570586" cy="109728"/>
+          </a:xfrm>
+          <a:prstGeom prst="roundRect">
+            <a:avLst>
+              <a:gd name="adj" fmla="val 50000"/>
+            </a:avLst>
+          </a:prstGeom>
+          <a:solidFill>
+            <a:srgbClr val="1B3A7A"/>
+          </a:solidFill>
+          <a:ln/>
+        </p:spPr>
+      </p:sp>
+      <p:sp>
+        <p:nvSpPr>
+          <p:cNvPr id="10" name="Etapa 3"/>
+          <p:cNvSpPr/>
+          <p:nvPr/>
+        </p:nvSpPr>
+        <p:spPr>
+          <a:xfrm>
+            <a:off x="9544508" y="5074920"/>
+            <a:ext cx="570586" cy="109728"/>
+          </a:xfrm>
+          <a:prstGeom prst="roundRect">
+            <a:avLst>
+              <a:gd name="adj" fmla="val 50000"/>
+            </a:avLst>
+          </a:prstGeom>
+          <a:solidFill>
+            <a:srgbClr val="1B3A7A"/>
+          </a:solidFill>
+          <a:ln/>
+        </p:spPr>
+      </p:sp>
+      <p:sp>
+        <p:nvSpPr>
+          <p:cNvPr id="11" name="Etapa 4"/>
+          <p:cNvSpPr/>
+          <p:nvPr/>
+        </p:nvSpPr>
+        <p:spPr>
+          <a:xfrm>
+            <a:off x="10224822" y="5074920"/>
+            <a:ext cx="570586" cy="109728"/>
+          </a:xfrm>
+          <a:prstGeom prst="roundRect">
+            <a:avLst>
+              <a:gd name="adj" fmla="val 50000"/>
+            </a:avLst>
+          </a:prstGeom>
+          <a:solidFill>
+            <a:srgbClr val="89D1FF"/>
+          </a:solidFill>
+          <a:ln/>
+        </p:spPr>
+      </p:sp>
+      <p:sp>
+        <p:nvSpPr>
+          <p:cNvPr id="12" name="Etapa 5"/>
+          <p:cNvSpPr/>
+          <p:nvPr/>
+        </p:nvSpPr>
+        <p:spPr>
+          <a:xfrm>
+            <a:off x="10905136" y="5074920"/>
+            <a:ext cx="570586" cy="109728"/>
+          </a:xfrm>
+          <a:prstGeom prst="roundRect">
+            <a:avLst>
+              <a:gd name="adj" fmla="val 50000"/>
+            </a:avLst>
+          </a:prstGeom>
+          <a:solidFill>
+            <a:srgbClr val="1B3A7A"/>
+          </a:solidFill>
+          <a:ln/>
+        </p:spPr>
+      </p:sp>
+      <p:sp>
+        <p:nvSpPr>
+          <p:cNvPr id="14" name="Text 11"/>
+          <p:cNvSpPr txBox="1"/>
+          <p:nvPr/>
+        </p:nvSpPr>
+        <p:spPr>
+          <a:xfrm>
+            <a:off x="8183880" y="5303520"/>
+            <a:ext cx="3291840" cy="274320"/>
+          </a:xfrm>
+          <a:prstGeom prst="rect">
             <a:avLst/>
           </a:prstGeom>
-          <a:solidFill>
-            <a:srgbClr val="1F4F86"/>
-          </a:solidFill>
-          <a:ln w="19050">
-            <a:solidFill>
-              <a:srgbClr val="1F4F86"/>
-            </a:solidFill>
-          </a:ln>
+          <a:noFill/>
+          <a:ln/>
         </p:spPr>
         <p:txBody>
           <a:bodyPr wrap="square" lIns="0" tIns="0" rIns="0" bIns="0" rtlCol="0" anchor="ctr"/>
           <a:lstStyle/>
           <a:p>
-            <a:pPr algn="ctr" indent="0" marL="0">
-              <a:buNone/>
-            </a:pPr>
-            <a:r>
-              <a:rPr lang="en-US" sz="1300" b="1" dirty="0">
-                <a:solidFill>
-                  <a:srgbClr val="FFFFFF"/>
-                </a:solidFill>
-              </a:rPr>
-              <a:t>1</a:t>
-            </a:r>
-            <a:endParaRPr lang="en-US" sz="1300" dirty="0"/>
+            <a:pPr indent="0" marL="0">
+              <a:buNone/>
+            </a:pPr>
+            <a:r>
+              <a:rPr lang="en-US" sz="1200" dirty="0">
+                <a:solidFill>
+                  <a:srgbClr val="89D1FF"/>
+                </a:solidFill>
+              </a:rPr>
+              <a:t>Etapa 4 de 5</a:t>
+            </a:r>
+            <a:endParaRPr lang="en-US" sz="1200" dirty="0"/>
           </a:p>
         </p:txBody>
       </p:sp>
       <p:sp>
         <p:nvSpPr>
-          <p:cNvPr id="9" name="Text 7"/>
+          <p:cNvPr id="40" name="Rodapé"/>
           <p:cNvSpPr txBox="1"/>
           <p:nvPr/>
         </p:nvSpPr>
         <p:spPr>
           <a:xfrm>
-            <a:off x="192024" y="5550408"/>
-            <a:ext cx="1463040" cy="274320"/>
+            <a:off x="731520" y="5989320"/>
+            <a:ext cx="7315200" cy="320040"/>
           </a:xfrm>
           <a:prstGeom prst="rect">
             <a:avLst/>
           </a:prstGeom>
           <a:noFill/>
-          <a:ln/>
         </p:spPr>
         <p:txBody>
-          <a:bodyPr wrap="square" lIns="0" tIns="0" rIns="0" bIns="0" rtlCol="0" anchor="ctr"/>
+          <a:bodyPr wrap="square" lIns="0" tIns="0" rIns="0" bIns="0" rtlCol="0" anchor="t"/>
           <a:lstStyle/>
           <a:p>
-            <a:pPr algn="ctr" indent="0" marL="0">
-              <a:buNone/>
-            </a:pPr>
-            <a:r>
-              <a:rPr lang="en-US" sz="1100" dirty="0">
-                <a:solidFill>
-                  <a:srgbClr val="A9B4BE"/>
-                </a:solidFill>
-              </a:rPr>
-              <a:t>Modelagem de dados</a:t>
-            </a:r>
-            <a:endParaRPr lang="en-US" sz="1100" dirty="0"/>
-          </a:p>
-        </p:txBody>
-      </p:sp>
-      <p:sp>
-        <p:nvSpPr>
-          <p:cNvPr id="10" name="Etapa 2"/>
-          <p:cNvSpPr/>
-          <p:nvPr/>
-        </p:nvSpPr>
-        <p:spPr>
-          <a:xfrm>
-            <a:off x="3264408" y="5074920"/>
-            <a:ext cx="384048" cy="384048"/>
-          </a:xfrm>
-          <a:prstGeom prst="ellipse">
-            <a:avLst/>
-          </a:prstGeom>
-          <a:solidFill>
-            <a:srgbClr val="1F4F86"/>
-          </a:solidFill>
-          <a:ln w="19050">
-            <a:solidFill>
-              <a:srgbClr val="1F4F86"/>
-            </a:solidFill>
-          </a:ln>
-        </p:spPr>
-        <p:txBody>
-          <a:bodyPr wrap="square" lIns="0" tIns="0" rIns="0" bIns="0" rtlCol="0" anchor="ctr"/>
-          <a:lstStyle/>
-          <a:p>
-            <a:pPr algn="ctr" indent="0" marL="0">
-              <a:buNone/>
-            </a:pPr>
-            <a:r>
-              <a:rPr lang="en-US" sz="1300" b="1" dirty="0">
-                <a:solidFill>
-                  <a:srgbClr val="FFFFFF"/>
-                </a:solidFill>
-              </a:rPr>
-              <a:t>2</a:t>
-            </a:r>
-            <a:endParaRPr lang="en-US" sz="1300" dirty="0"/>
-          </a:p>
-        </p:txBody>
-      </p:sp>
-      <p:sp>
-        <p:nvSpPr>
-          <p:cNvPr id="11" name="Text 9"/>
-          <p:cNvSpPr txBox="1"/>
-          <p:nvPr/>
-        </p:nvSpPr>
-        <p:spPr>
-          <a:xfrm>
-            <a:off x="2724912" y="5550408"/>
-            <a:ext cx="1463040" cy="274320"/>
-          </a:xfrm>
-          <a:prstGeom prst="rect">
-            <a:avLst/>
-          </a:prstGeom>
-          <a:noFill/>
-          <a:ln/>
-        </p:spPr>
-        <p:txBody>
-          <a:bodyPr wrap="square" lIns="0" tIns="0" rIns="0" bIns="0" rtlCol="0" anchor="ctr"/>
-          <a:lstStyle/>
-          <a:p>
-            <a:pPr algn="ctr" indent="0" marL="0">
-              <a:buNone/>
-            </a:pPr>
-            <a:r>
-              <a:rPr lang="en-US" sz="1100" dirty="0">
-                <a:solidFill>
-                  <a:srgbClr val="A9B4BE"/>
-                </a:solidFill>
-              </a:rPr>
-              <a:t>Core Data Services</a:t>
-            </a:r>
-            <a:endParaRPr lang="en-US" sz="1100" dirty="0"/>
-          </a:p>
-        </p:txBody>
-      </p:sp>
-      <p:sp>
-        <p:nvSpPr>
-          <p:cNvPr id="12" name="Etapa 3"/>
-          <p:cNvSpPr/>
-          <p:nvPr/>
-        </p:nvSpPr>
-        <p:spPr>
-          <a:xfrm>
-            <a:off x="5797296" y="5074920"/>
-            <a:ext cx="384048" cy="384048"/>
-          </a:xfrm>
-          <a:prstGeom prst="ellipse">
-            <a:avLst/>
-          </a:prstGeom>
-          <a:solidFill>
-            <a:srgbClr val="1F4F86"/>
-          </a:solidFill>
-          <a:ln w="19050">
-            <a:solidFill>
-              <a:srgbClr val="1F4F86"/>
-            </a:solidFill>
-          </a:ln>
-        </p:spPr>
-        <p:txBody>
-          <a:bodyPr wrap="square" lIns="0" tIns="0" rIns="0" bIns="0" rtlCol="0" anchor="ctr"/>
-          <a:lstStyle/>
-          <a:p>
-            <a:pPr algn="ctr" indent="0" marL="0">
-              <a:buNone/>
-            </a:pPr>
-            <a:r>
-              <a:rPr lang="en-US" sz="1300" b="1" dirty="0">
-                <a:solidFill>
-                  <a:srgbClr val="FFFFFF"/>
-                </a:solidFill>
-              </a:rPr>
-              <a:t>3</a:t>
-            </a:r>
-            <a:endParaRPr lang="en-US" sz="1300" dirty="0"/>
-          </a:p>
-        </p:txBody>
-      </p:sp>
-      <p:sp>
-        <p:nvSpPr>
-          <p:cNvPr id="13" name="Text 11"/>
-          <p:cNvSpPr txBox="1"/>
-          <p:nvPr/>
-        </p:nvSpPr>
-        <p:spPr>
-          <a:xfrm>
-            <a:off x="5257800" y="5550408"/>
-            <a:ext cx="1463040" cy="274320"/>
-          </a:xfrm>
-          <a:prstGeom prst="rect">
-            <a:avLst/>
-          </a:prstGeom>
-          <a:noFill/>
-          <a:ln/>
-        </p:spPr>
-        <p:txBody>
-          <a:bodyPr wrap="square" lIns="0" tIns="0" rIns="0" bIns="0" rtlCol="0" anchor="ctr"/>
-          <a:lstStyle/>
-          <a:p>
-            <a:pPr algn="ctr" indent="0" marL="0">
-              <a:buNone/>
-            </a:pPr>
-            <a:r>
-              <a:rPr lang="en-US" sz="1100" dirty="0">
-                <a:solidFill>
-                  <a:srgbClr val="A9B4BE"/>
-                </a:solidFill>
-              </a:rPr>
-              <a:t>Comportamento RAP</a:t>
-            </a:r>
-            <a:endParaRPr lang="en-US" sz="1100" dirty="0"/>
-          </a:p>
-        </p:txBody>
-      </p:sp>
-      <p:sp>
-        <p:nvSpPr>
-          <p:cNvPr id="14" name="Etapa 4"/>
-          <p:cNvSpPr/>
-          <p:nvPr/>
-        </p:nvSpPr>
-        <p:spPr>
-          <a:xfrm>
-            <a:off x="8330184" y="5074920"/>
-            <a:ext cx="384048" cy="384048"/>
-          </a:xfrm>
-          <a:prstGeom prst="ellipse">
-            <a:avLst/>
-          </a:prstGeom>
-          <a:solidFill>
-            <a:srgbClr val="0070F2"/>
-          </a:solidFill>
-          <a:ln w="19050">
-            <a:solidFill>
-              <a:srgbClr val="0070F2"/>
-            </a:solidFill>
-          </a:ln>
-        </p:spPr>
-        <p:txBody>
-          <a:bodyPr wrap="square" lIns="0" tIns="0" rIns="0" bIns="0" rtlCol="0" anchor="ctr"/>
-          <a:lstStyle/>
-          <a:p>
-            <a:pPr algn="ctr" indent="0" marL="0">
-              <a:buNone/>
-            </a:pPr>
-            <a:r>
-              <a:rPr lang="en-US" sz="1300" b="1" dirty="0">
-                <a:solidFill>
-                  <a:srgbClr val="FFFFFF"/>
-                </a:solidFill>
-              </a:rPr>
-              <a:t>4</a:t>
-            </a:r>
-            <a:endParaRPr lang="en-US" sz="1300" dirty="0"/>
-          </a:p>
-        </p:txBody>
-      </p:sp>
-      <p:sp>
-        <p:nvSpPr>
-          <p:cNvPr id="15" name="Text 13"/>
-          <p:cNvSpPr txBox="1"/>
-          <p:nvPr/>
-        </p:nvSpPr>
-        <p:spPr>
-          <a:xfrm>
-            <a:off x="7790688" y="5550408"/>
-            <a:ext cx="1463040" cy="274320"/>
-          </a:xfrm>
-          <a:prstGeom prst="rect">
-            <a:avLst/>
-          </a:prstGeom>
-          <a:noFill/>
-          <a:ln/>
-        </p:spPr>
-        <p:txBody>
-          <a:bodyPr wrap="square" lIns="0" tIns="0" rIns="0" bIns="0" rtlCol="0" anchor="ctr"/>
-          <a:lstStyle/>
-          <a:p>
-            <a:pPr algn="ctr" indent="0" marL="0">
-              <a:buNone/>
-            </a:pPr>
-            <a:r>
-              <a:rPr lang="en-US" sz="1100" b="1" dirty="0">
-                <a:solidFill>
-                  <a:srgbClr val="FFFFFF"/>
-                </a:solidFill>
-              </a:rPr>
-              <a:t>Serviços OData</a:t>
-            </a:r>
-            <a:endParaRPr lang="en-US" sz="1100" dirty="0"/>
-          </a:p>
-        </p:txBody>
-      </p:sp>
-      <p:sp>
-        <p:nvSpPr>
-          <p:cNvPr id="16" name="Etapa 5"/>
-          <p:cNvSpPr/>
-          <p:nvPr/>
-        </p:nvSpPr>
-        <p:spPr>
-          <a:xfrm>
-            <a:off x="10863072" y="5074920"/>
-            <a:ext cx="384048" cy="384048"/>
-          </a:xfrm>
-          <a:prstGeom prst="ellipse">
-            <a:avLst/>
-          </a:prstGeom>
-          <a:solidFill>
-            <a:srgbClr val="1D232A"/>
-          </a:solidFill>
-          <a:ln w="19050">
-            <a:solidFill>
-              <a:srgbClr val="3A4654"/>
-            </a:solidFill>
-          </a:ln>
-        </p:spPr>
-        <p:txBody>
-          <a:bodyPr wrap="square" lIns="0" tIns="0" rIns="0" bIns="0" rtlCol="0" anchor="ctr"/>
-          <a:lstStyle/>
-          <a:p>
-            <a:pPr algn="ctr" indent="0" marL="0">
-              <a:buNone/>
-            </a:pPr>
-            <a:r>
-              <a:rPr lang="en-US" sz="1300" b="1" dirty="0">
-                <a:solidFill>
-                  <a:srgbClr val="A9B4BE"/>
-                </a:solidFill>
-              </a:rPr>
-              <a:t>5</a:t>
-            </a:r>
-            <a:endParaRPr lang="en-US" sz="1300" dirty="0"/>
-          </a:p>
-        </p:txBody>
-      </p:sp>
-      <p:sp>
-        <p:nvSpPr>
-          <p:cNvPr id="17" name="Text 15"/>
-          <p:cNvSpPr txBox="1"/>
-          <p:nvPr/>
-        </p:nvSpPr>
-        <p:spPr>
-          <a:xfrm>
-            <a:off x="10323576" y="5550408"/>
-            <a:ext cx="1463040" cy="274320"/>
-          </a:xfrm>
-          <a:prstGeom prst="rect">
-            <a:avLst/>
-          </a:prstGeom>
-          <a:noFill/>
-          <a:ln/>
-        </p:spPr>
-        <p:txBody>
-          <a:bodyPr wrap="square" lIns="0" tIns="0" rIns="0" bIns="0" rtlCol="0" anchor="ctr"/>
-          <a:lstStyle/>
-          <a:p>
-            <a:pPr algn="ctr" indent="0" marL="0">
-              <a:buNone/>
-            </a:pPr>
-            <a:r>
-              <a:rPr lang="en-US" sz="1100" dirty="0">
-                <a:solidFill>
-                  <a:srgbClr val="A9B4BE"/>
-                </a:solidFill>
-              </a:rPr>
-              <a:t>Apps Fiori</a:t>
-            </a:r>
-            <a:endParaRPr lang="en-US" sz="1100" dirty="0"/>
+            <a:r>
+              <a:rPr lang="pt-BR" sz="1200" dirty="0">
+                <a:solidFill>
+                  <a:srgbClr val="89D1FF"/>
+                </a:solidFill>
+              </a:rPr>
+              <a:t>Pedidos de Compras · SAP RAP no BTP e On-Premise · Design System SAP Horizon</a:t>
+            </a:r>
           </a:p>
         </p:txBody>
       </p:sp>
@@ -8955,7 +8743,7 @@
             <a:r>
               <a:rPr lang="en-US" sz="1400" b="1" spc="200" kern="0" dirty="0">
                 <a:solidFill>
-                  <a:schemeClr val="accent1"/>
+                  <a:srgbClr val="89D1FF"/>
                 </a:solidFill>
               </a:rPr>
               <a:t>ETAPA 4 · CLIENTES</a:t>
@@ -9042,50 +8830,6 @@
       </p:sp>
       <p:sp>
         <p:nvSpPr>
-          <p:cNvPr id="5" name="Decoração 1"/>
-          <p:cNvSpPr/>
-          <p:nvPr/>
-        </p:nvSpPr>
-        <p:spPr>
-          <a:xfrm>
-            <a:off x="8503920" y="-1463040"/>
-            <a:ext cx="5120640" cy="5120640"/>
-          </a:xfrm>
-          <a:prstGeom prst="ellipse">
-            <a:avLst/>
-          </a:prstGeom>
-          <a:solidFill>
-            <a:srgbClr val="0070F2">
-              <a:alpha val="28000"/>
-            </a:srgbClr>
-          </a:solidFill>
-          <a:ln/>
-        </p:spPr>
-      </p:sp>
-      <p:sp>
-        <p:nvSpPr>
-          <p:cNvPr id="6" name="Decoração 2"/>
-          <p:cNvSpPr/>
-          <p:nvPr/>
-        </p:nvSpPr>
-        <p:spPr>
-          <a:xfrm>
-            <a:off x="9784080" y="1828800"/>
-            <a:ext cx="2834640" cy="2834640"/>
-          </a:xfrm>
-          <a:prstGeom prst="ellipse">
-            <a:avLst/>
-          </a:prstGeom>
-          <a:solidFill>
-            <a:srgbClr val="4DB1FF">
-              <a:alpha val="18000"/>
-            </a:srgbClr>
-          </a:solidFill>
-          <a:ln/>
-        </p:spPr>
-      </p:sp>
-      <p:sp>
-        <p:nvSpPr>
           <p:cNvPr id="7" name="Ícone customer"/>
           <p:cNvSpPr/>
           <p:nvPr/>
@@ -9101,7 +8845,7 @@
             </a:avLst>
           </a:prstGeom>
           <a:solidFill>
-            <a:srgbClr val="1D232A"/>
+            <a:srgbClr val="1B3A7A"/>
           </a:solidFill>
           <a:ln/>
         </p:spPr>
@@ -9147,7 +8891,7 @@
             </a:avLst>
           </a:prstGeom>
           <a:solidFill>
-            <a:srgbClr val="1D232A"/>
+            <a:srgbClr val="1B3A7A"/>
           </a:solidFill>
           <a:ln/>
         </p:spPr>
@@ -9179,7 +8923,7 @@
             <a:r>
               <a:rPr lang="en-US" sz="1100" b="1" spc="150" kern="0" dirty="0">
                 <a:solidFill>
-                  <a:srgbClr val="4DB1FF"/>
+                  <a:srgbClr val="89D1FF"/>
                 </a:solidFill>
               </a:rPr>
               <a:t>OBJETOS NESTA SEÇÃO</a:t>
@@ -9229,7 +8973,7 @@
             <a:r>
               <a:rPr lang="en-US" sz="1100" dirty="0">
                 <a:solidFill>
-                  <a:srgbClr val="A9B4BE"/>
+                  <a:srgbClr val="D1EFFF"/>
                 </a:solidFill>
               </a:rPr>
               <a:t>  service definition</a:t>
@@ -9279,7 +9023,7 @@
             <a:r>
               <a:rPr lang="en-US" sz="1100" dirty="0">
                 <a:solidFill>
-                  <a:srgbClr val="A9B4BE"/>
+                  <a:srgbClr val="D1EFFF"/>
                 </a:solidFill>
               </a:rPr>
               <a:t>  service binding</a:t>
@@ -9329,7 +9073,7 @@
             <a:r>
               <a:rPr lang="en-US" sz="1100" dirty="0">
                 <a:solidFill>
-                  <a:srgbClr val="A9B4BE"/>
+                  <a:srgbClr val="D1EFFF"/>
                 </a:solidFill>
               </a:rPr>
               <a:t>  projeção</a:t>
@@ -9379,7 +9123,7 @@
             <a:r>
               <a:rPr lang="en-US" sz="1100" dirty="0">
                 <a:solidFill>
-                  <a:srgbClr val="A9B4BE"/>
+                  <a:srgbClr val="D1EFFF"/>
                 </a:solidFill>
               </a:rPr>
               <a:t>  IAM App</a:t>
@@ -11999,7 +11743,7 @@
             <a:r>
               <a:rPr lang="en-US" sz="1400" b="1" spc="200" kern="0" dirty="0">
                 <a:solidFill>
-                  <a:schemeClr val="accent1"/>
+                  <a:srgbClr val="89D1FF"/>
                 </a:solidFill>
               </a:rPr>
               <a:t>ETAPA 4 · ESTOQUE</a:t>
@@ -12086,50 +11830,6 @@
       </p:sp>
       <p:sp>
         <p:nvSpPr>
-          <p:cNvPr id="5" name="Decoração 1"/>
-          <p:cNvSpPr/>
-          <p:nvPr/>
-        </p:nvSpPr>
-        <p:spPr>
-          <a:xfrm>
-            <a:off x="8503920" y="-1463040"/>
-            <a:ext cx="5120640" cy="5120640"/>
-          </a:xfrm>
-          <a:prstGeom prst="ellipse">
-            <a:avLst/>
-          </a:prstGeom>
-          <a:solidFill>
-            <a:srgbClr val="0070F2">
-              <a:alpha val="28000"/>
-            </a:srgbClr>
-          </a:solidFill>
-          <a:ln/>
-        </p:spPr>
-      </p:sp>
-      <p:sp>
-        <p:nvSpPr>
-          <p:cNvPr id="6" name="Decoração 2"/>
-          <p:cNvSpPr/>
-          <p:nvPr/>
-        </p:nvSpPr>
-        <p:spPr>
-          <a:xfrm>
-            <a:off x="9784080" y="1828800"/>
-            <a:ext cx="2834640" cy="2834640"/>
-          </a:xfrm>
-          <a:prstGeom prst="ellipse">
-            <a:avLst/>
-          </a:prstGeom>
-          <a:solidFill>
-            <a:srgbClr val="4DB1FF">
-              <a:alpha val="18000"/>
-            </a:srgbClr>
-          </a:solidFill>
-          <a:ln/>
-        </p:spPr>
-      </p:sp>
-      <p:sp>
-        <p:nvSpPr>
           <p:cNvPr id="7" name="Ícone product"/>
           <p:cNvSpPr/>
           <p:nvPr/>
@@ -12145,7 +11845,7 @@
             </a:avLst>
           </a:prstGeom>
           <a:solidFill>
-            <a:srgbClr val="1D232A"/>
+            <a:srgbClr val="1B3A7A"/>
           </a:solidFill>
           <a:ln/>
         </p:spPr>
@@ -12191,7 +11891,7 @@
             </a:avLst>
           </a:prstGeom>
           <a:solidFill>
-            <a:srgbClr val="1D232A"/>
+            <a:srgbClr val="1B3A7A"/>
           </a:solidFill>
           <a:ln/>
         </p:spPr>
@@ -12223,7 +11923,7 @@
             <a:r>
               <a:rPr lang="en-US" sz="1100" b="1" spc="150" kern="0" dirty="0">
                 <a:solidFill>
-                  <a:srgbClr val="4DB1FF"/>
+                  <a:srgbClr val="89D1FF"/>
                 </a:solidFill>
               </a:rPr>
               <a:t>OBJETOS NESTA SEÇÃO</a:t>
@@ -12273,7 +11973,7 @@
             <a:r>
               <a:rPr lang="en-US" sz="1100" dirty="0">
                 <a:solidFill>
-                  <a:srgbClr val="A9B4BE"/>
+                  <a:srgbClr val="D1EFFF"/>
                 </a:solidFill>
               </a:rPr>
               <a:t>  service definition</a:t>
@@ -12323,7 +12023,7 @@
             <a:r>
               <a:rPr lang="en-US" sz="1100" dirty="0">
                 <a:solidFill>
-                  <a:srgbClr val="A9B4BE"/>
+                  <a:srgbClr val="D1EFFF"/>
                 </a:solidFill>
               </a:rPr>
               <a:t>  service binding</a:t>
@@ -12373,7 +12073,7 @@
             <a:r>
               <a:rPr lang="en-US" sz="1100" dirty="0">
                 <a:solidFill>
-                  <a:srgbClr val="A9B4BE"/>
+                  <a:srgbClr val="D1EFFF"/>
                 </a:solidFill>
               </a:rPr>
               <a:t>  projeção</a:t>
@@ -12423,7 +12123,7 @@
             <a:r>
               <a:rPr lang="en-US" sz="1100" dirty="0">
                 <a:solidFill>
-                  <a:srgbClr val="A9B4BE"/>
+                  <a:srgbClr val="D1EFFF"/>
                 </a:solidFill>
               </a:rPr>
               <a:t>  IAM App</a:t>
@@ -15043,7 +14743,7 @@
             <a:r>
               <a:rPr lang="en-US" sz="1400" b="1" spc="200" kern="0" dirty="0">
                 <a:solidFill>
-                  <a:schemeClr val="accent1"/>
+                  <a:srgbClr val="89D1FF"/>
                 </a:solidFill>
               </a:rPr>
               <a:t>ETAPA 4 · PEDIDOS</a:t>
@@ -15130,50 +14830,6 @@
       </p:sp>
       <p:sp>
         <p:nvSpPr>
-          <p:cNvPr id="5" name="Decoração 1"/>
-          <p:cNvSpPr/>
-          <p:nvPr/>
-        </p:nvSpPr>
-        <p:spPr>
-          <a:xfrm>
-            <a:off x="8503920" y="-1463040"/>
-            <a:ext cx="5120640" cy="5120640"/>
-          </a:xfrm>
-          <a:prstGeom prst="ellipse">
-            <a:avLst/>
-          </a:prstGeom>
-          <a:solidFill>
-            <a:srgbClr val="0070F2">
-              <a:alpha val="28000"/>
-            </a:srgbClr>
-          </a:solidFill>
-          <a:ln/>
-        </p:spPr>
-      </p:sp>
-      <p:sp>
-        <p:nvSpPr>
-          <p:cNvPr id="6" name="Decoração 2"/>
-          <p:cNvSpPr/>
-          <p:nvPr/>
-        </p:nvSpPr>
-        <p:spPr>
-          <a:xfrm>
-            <a:off x="9784080" y="1828800"/>
-            <a:ext cx="2834640" cy="2834640"/>
-          </a:xfrm>
-          <a:prstGeom prst="ellipse">
-            <a:avLst/>
-          </a:prstGeom>
-          <a:solidFill>
-            <a:srgbClr val="4DB1FF">
-              <a:alpha val="18000"/>
-            </a:srgbClr>
-          </a:solidFill>
-          <a:ln/>
-        </p:spPr>
-      </p:sp>
-      <p:sp>
-        <p:nvSpPr>
           <p:cNvPr id="7" name="Ícone sales-order"/>
           <p:cNvSpPr/>
           <p:nvPr/>
@@ -15189,7 +14845,7 @@
             </a:avLst>
           </a:prstGeom>
           <a:solidFill>
-            <a:srgbClr val="1D232A"/>
+            <a:srgbClr val="1B3A7A"/>
           </a:solidFill>
           <a:ln/>
         </p:spPr>
@@ -15235,7 +14891,7 @@
             </a:avLst>
           </a:prstGeom>
           <a:solidFill>
-            <a:srgbClr val="1D232A"/>
+            <a:srgbClr val="1B3A7A"/>
           </a:solidFill>
           <a:ln/>
         </p:spPr>
@@ -15267,7 +14923,7 @@
             <a:r>
               <a:rPr lang="en-US" sz="1100" b="1" spc="150" kern="0" dirty="0">
                 <a:solidFill>
-                  <a:srgbClr val="4DB1FF"/>
+                  <a:srgbClr val="89D1FF"/>
                 </a:solidFill>
               </a:rPr>
               <a:t>OBJETOS NESTA SEÇÃO</a:t>
@@ -15317,7 +14973,7 @@
             <a:r>
               <a:rPr lang="en-US" sz="1100" dirty="0">
                 <a:solidFill>
-                  <a:srgbClr val="A9B4BE"/>
+                  <a:srgbClr val="D1EFFF"/>
                 </a:solidFill>
               </a:rPr>
               <a:t>  service definition</a:t>
@@ -15367,7 +15023,7 @@
             <a:r>
               <a:rPr lang="en-US" sz="1100" dirty="0">
                 <a:solidFill>
-                  <a:srgbClr val="A9B4BE"/>
+                  <a:srgbClr val="D1EFFF"/>
                 </a:solidFill>
               </a:rPr>
               <a:t>  service binding</a:t>
@@ -15417,7 +15073,7 @@
             <a:r>
               <a:rPr lang="en-US" sz="1100" dirty="0">
                 <a:solidFill>
-                  <a:srgbClr val="A9B4BE"/>
+                  <a:srgbClr val="D1EFFF"/>
                 </a:solidFill>
               </a:rPr>
               <a:t>  projeção</a:t>
@@ -15467,7 +15123,7 @@
             <a:r>
               <a:rPr lang="en-US" sz="1100" dirty="0">
                 <a:solidFill>
-                  <a:srgbClr val="A9B4BE"/>
+                  <a:srgbClr val="D1EFFF"/>
                 </a:solidFill>
               </a:rPr>
               <a:t>  IAM App</a:t>
@@ -19342,7 +18998,7 @@
             <a:r>
               <a:rPr lang="en-US" sz="1400" b="1" spc="200" kern="0" dirty="0">
                 <a:solidFill>
-                  <a:schemeClr val="accent1"/>
+                  <a:srgbClr val="89D1FF"/>
                 </a:solidFill>
               </a:rPr>
               <a:t>ETAPA 4 · REEMBOLSOS</a:t>
@@ -19429,50 +19085,6 @@
       </p:sp>
       <p:sp>
         <p:nvSpPr>
-          <p:cNvPr id="5" name="Decoração 1"/>
-          <p:cNvSpPr/>
-          <p:nvPr/>
-        </p:nvSpPr>
-        <p:spPr>
-          <a:xfrm>
-            <a:off x="8503920" y="-1463040"/>
-            <a:ext cx="5120640" cy="5120640"/>
-          </a:xfrm>
-          <a:prstGeom prst="ellipse">
-            <a:avLst/>
-          </a:prstGeom>
-          <a:solidFill>
-            <a:srgbClr val="0070F2">
-              <a:alpha val="28000"/>
-            </a:srgbClr>
-          </a:solidFill>
-          <a:ln/>
-        </p:spPr>
-      </p:sp>
-      <p:sp>
-        <p:nvSpPr>
-          <p:cNvPr id="6" name="Decoração 2"/>
-          <p:cNvSpPr/>
-          <p:nvPr/>
-        </p:nvSpPr>
-        <p:spPr>
-          <a:xfrm>
-            <a:off x="9784080" y="1828800"/>
-            <a:ext cx="2834640" cy="2834640"/>
-          </a:xfrm>
-          <a:prstGeom prst="ellipse">
-            <a:avLst/>
-          </a:prstGeom>
-          <a:solidFill>
-            <a:srgbClr val="4DB1FF">
-              <a:alpha val="18000"/>
-            </a:srgbClr>
-          </a:solidFill>
-          <a:ln/>
-        </p:spPr>
-      </p:sp>
-      <p:sp>
-        <p:nvSpPr>
           <p:cNvPr id="7" name="Ícone money-bills"/>
           <p:cNvSpPr/>
           <p:nvPr/>
@@ -19488,7 +19100,7 @@
             </a:avLst>
           </a:prstGeom>
           <a:solidFill>
-            <a:srgbClr val="1D232A"/>
+            <a:srgbClr val="1B3A7A"/>
           </a:solidFill>
           <a:ln/>
         </p:spPr>
@@ -19534,7 +19146,7 @@
             </a:avLst>
           </a:prstGeom>
           <a:solidFill>
-            <a:srgbClr val="1D232A"/>
+            <a:srgbClr val="1B3A7A"/>
           </a:solidFill>
           <a:ln/>
         </p:spPr>
@@ -19566,7 +19178,7 @@
             <a:r>
               <a:rPr lang="en-US" sz="1100" b="1" spc="150" kern="0" dirty="0">
                 <a:solidFill>
-                  <a:srgbClr val="4DB1FF"/>
+                  <a:srgbClr val="89D1FF"/>
                 </a:solidFill>
               </a:rPr>
               <a:t>OBJETOS NESTA SEÇÃO</a:t>
@@ -19616,7 +19228,7 @@
             <a:r>
               <a:rPr lang="en-US" sz="1100" dirty="0">
                 <a:solidFill>
-                  <a:srgbClr val="A9B4BE"/>
+                  <a:srgbClr val="D1EFFF"/>
                 </a:solidFill>
               </a:rPr>
               <a:t>  service definition</a:t>
@@ -19666,7 +19278,7 @@
             <a:r>
               <a:rPr lang="en-US" sz="1100" dirty="0">
                 <a:solidFill>
-                  <a:srgbClr val="A9B4BE"/>
+                  <a:srgbClr val="D1EFFF"/>
                 </a:solidFill>
               </a:rPr>
               <a:t>  service binding</a:t>
@@ -19716,7 +19328,7 @@
             <a:r>
               <a:rPr lang="en-US" sz="1100" dirty="0">
                 <a:solidFill>
-                  <a:srgbClr val="A9B4BE"/>
+                  <a:srgbClr val="D1EFFF"/>
                 </a:solidFill>
               </a:rPr>
               <a:t>  projeção</a:t>
@@ -19766,7 +19378,7 @@
             <a:r>
               <a:rPr lang="en-US" sz="1100" dirty="0">
                 <a:solidFill>
-                  <a:srgbClr val="A9B4BE"/>
+                  <a:srgbClr val="D1EFFF"/>
                 </a:solidFill>
               </a:rPr>
               <a:t>  IAM App</a:t>
@@ -19816,7 +19428,7 @@
             <a:r>
               <a:rPr lang="en-US" sz="1100" dirty="0">
                 <a:solidFill>
-                  <a:srgbClr val="A9B4BE"/>
+                  <a:srgbClr val="D1EFFF"/>
                 </a:solidFill>
               </a:rPr>
               <a:t>  SCO2 · SUSH · SIA6</a:t>
@@ -26020,8 +25632,8 @@
         </p:nvSpPr>
         <p:spPr>
           <a:xfrm>
-            <a:off x="731520" y="1325880"/>
-            <a:ext cx="6949440" cy="365760"/>
+            <a:off x="731520" y="548640"/>
+            <a:ext cx="7315200" cy="365760"/>
           </a:xfrm>
           <a:prstGeom prst="rect">
             <a:avLst/>
@@ -26039,10 +25651,10 @@
             <a:r>
               <a:rPr lang="en-US" sz="1400" b="1" spc="200" kern="0" dirty="0">
                 <a:solidFill>
-                  <a:schemeClr val="accent1"/>
-                </a:solidFill>
-              </a:rPr>
-              <a:t>ETAPA 4 CONCLUÍDA</a:t>
+                  <a:srgbClr val="89D1FF"/>
+                </a:solidFill>
+              </a:rPr>
+              <a:t>RESUMO DA ETAPA</a:t>
             </a:r>
             <a:endParaRPr lang="en-US" sz="1400" dirty="0"/>
           </a:p>
@@ -26058,8 +25670,90 @@
         </p:nvSpPr>
         <p:spPr>
           <a:xfrm>
-            <a:off x="731520" y="1737360"/>
-            <a:ext cx="6949440" cy="1600200"/>
+            <a:off x="731520" y="960120"/>
+            <a:ext cx="10698480" cy="822960"/>
+          </a:xfrm>
+          <a:prstGeom prst="rect">
+            <a:avLst/>
+          </a:prstGeom>
+          <a:noFill/>
+          <a:ln/>
+        </p:spPr>
+        <p:txBody>
+          <a:bodyPr wrap="square" lIns="0" tIns="0" rIns="0" bIns="0" rtlCol="0" anchor="ctr"/>
+          <a:lstStyle/>
+          <a:p>
+            <a:pPr algn="l" indent="0" marL="0">
+              <a:buNone/>
+            </a:pPr>
+            <a:r>
+              <a:rPr lang="en-US" sz="3600" b="1" dirty="0">
+                <a:solidFill>
+                  <a:schemeClr val="bg1"/>
+                </a:solidFill>
+              </a:rPr>
+              <a:t>O que construímos na etapa 4</a:t>
+            </a:r>
+            <a:endParaRPr lang="en-US" sz="3600" dirty="0"/>
+          </a:p>
+        </p:txBody>
+      </p:sp>
+      <p:sp>
+        <p:nvSpPr>
+          <p:cNvPr id="4" name="Marcador"/>
+          <p:cNvSpPr/>
+          <p:nvPr/>
+        </p:nvSpPr>
+        <p:spPr>
+          <a:xfrm>
+            <a:off x="731520" y="2103120"/>
+            <a:ext cx="457200" cy="457200"/>
+          </a:xfrm>
+          <a:prstGeom prst="roundRect">
+            <a:avLst>
+              <a:gd name="adj" fmla="val 22000"/>
+            </a:avLst>
+          </a:prstGeom>
+          <a:solidFill>
+            <a:schemeClr val="accent1"/>
+          </a:solidFill>
+          <a:ln/>
+        </p:spPr>
+      </p:sp>
+      <p:pic>
+        <p:nvPicPr>
+          <p:cNvPr id="5" name="Image 0" descr="concluído">    </p:cNvPr>
+          <p:cNvPicPr>
+            <a:picLocks noChangeAspect="1"/>
+          </p:cNvPicPr>
+          <p:nvPr/>
+        </p:nvPicPr>
+        <p:blipFill>
+          <a:blip r:embed="rId100"/>
+          <a:stretch>
+            <a:fillRect/>
+          </a:stretch>
+        </p:blipFill>
+        <p:spPr>
+          <a:xfrm>
+            <a:off x="832104" y="2203704"/>
+            <a:ext cx="256032" cy="256032"/>
+          </a:xfrm>
+          <a:prstGeom prst="rect">
+            <a:avLst/>
+          </a:prstGeom>
+        </p:spPr>
+      </p:pic>
+      <p:sp>
+        <p:nvSpPr>
+          <p:cNvPr id="6" name="Text 3"/>
+          <p:cNvSpPr txBox="1"/>
+          <p:nvPr/>
+        </p:nvSpPr>
+        <p:spPr>
+          <a:xfrm>
+            <a:off x="1371600" y="2029968"/>
+            <a:ext cx="4526280" cy="777240"/>
           </a:xfrm>
           <a:prstGeom prst="rect">
             <a:avLst/>
@@ -26071,33 +25765,77 @@
           <a:bodyPr wrap="square" lIns="0" tIns="0" rIns="0" bIns="0" rtlCol="0" anchor="t"/>
           <a:lstStyle/>
           <a:p>
-            <a:pPr algn="l" indent="0" marL="0">
-              <a:buNone/>
-            </a:pPr>
-            <a:r>
-              <a:rPr lang="en-US" sz="4400" b="1" dirty="0">
-                <a:solidFill>
-                  <a:schemeClr val="bg1"/>
-                </a:solidFill>
-              </a:rPr>
-              <a:t>Serviços publicados</a:t>
-            </a:r>
-            <a:endParaRPr lang="en-US" sz="4400" dirty="0"/>
+            <a:pPr indent="0" marL="0">
+              <a:buNone/>
+            </a:pPr>
+            <a:r>
+              <a:rPr lang="en-US" sz="1500" dirty="0">
+                <a:solidFill>
+                  <a:srgbClr val="FFFFFF"/>
+                </a:solidFill>
+              </a:rPr>
+              <a:t>Cinco service definitions e bindings OData V4 – UI</a:t>
+            </a:r>
+            <a:endParaRPr lang="en-US" sz="1500" dirty="0"/>
           </a:p>
         </p:txBody>
       </p:sp>
       <p:sp>
         <p:nvSpPr>
-          <p:cNvPr id="4" name="Text 0"/>
+          <p:cNvPr id="7" name="Marcador"/>
           <p:cNvSpPr/>
-          <p:nvPr>
-            <p:ph idx="102" type="body" hasCustomPrompt="1"/>
-          </p:nvPr>
-        </p:nvSpPr>
-        <p:spPr>
-          <a:xfrm>
-            <a:off x="731520" y="3383280"/>
-            <a:ext cx="6949440" cy="914400"/>
+          <p:nvPr/>
+        </p:nvSpPr>
+        <p:spPr>
+          <a:xfrm>
+            <a:off x="6263640" y="2103120"/>
+            <a:ext cx="457200" cy="457200"/>
+          </a:xfrm>
+          <a:prstGeom prst="roundRect">
+            <a:avLst>
+              <a:gd name="adj" fmla="val 22000"/>
+            </a:avLst>
+          </a:prstGeom>
+          <a:solidFill>
+            <a:schemeClr val="accent1"/>
+          </a:solidFill>
+          <a:ln/>
+        </p:spPr>
+      </p:sp>
+      <p:pic>
+        <p:nvPicPr>
+          <p:cNvPr id="8" name="Image 1" descr="concluído">    </p:cNvPr>
+          <p:cNvPicPr>
+            <a:picLocks noChangeAspect="1"/>
+          </p:cNvPicPr>
+          <p:nvPr/>
+        </p:nvPicPr>
+        <p:blipFill>
+          <a:blip r:embed="rId101"/>
+          <a:stretch>
+            <a:fillRect/>
+          </a:stretch>
+        </p:blipFill>
+        <p:spPr>
+          <a:xfrm>
+            <a:off x="6364224" y="2203704"/>
+            <a:ext cx="256032" cy="256032"/>
+          </a:xfrm>
+          <a:prstGeom prst="rect">
+            <a:avLst/>
+          </a:prstGeom>
+        </p:spPr>
+      </p:pic>
+      <p:sp>
+        <p:nvSpPr>
+          <p:cNvPr id="9" name="Text 5"/>
+          <p:cNvSpPr txBox="1"/>
+          <p:nvPr/>
+        </p:nvSpPr>
+        <p:spPr>
+          <a:xfrm>
+            <a:off x="6903720" y="2029968"/>
+            <a:ext cx="4526280" cy="777240"/>
           </a:xfrm>
           <a:prstGeom prst="rect">
             <a:avLst/>
@@ -26109,569 +25847,470 @@
           <a:bodyPr wrap="square" lIns="0" tIns="0" rIns="0" bIns="0" rtlCol="0" anchor="t"/>
           <a:lstStyle/>
           <a:p>
-            <a:pPr algn="l" indent="0" marL="0">
-              <a:buNone/>
-            </a:pPr>
-            <a:r>
-              <a:rPr lang="en-US" sz="1800" dirty="0">
-                <a:solidFill>
-                  <a:schemeClr val="bg2"/>
-                </a:solidFill>
-              </a:rPr>
-              <a:t>Cinco serviços OData V4, BDEFs de projeção, objetos de autorização, IAM Apps (BTP) ou roles PFCG (On-Premise) e dados de demonstração.</a:t>
-            </a:r>
-            <a:endParaRPr lang="en-US" sz="1800" dirty="0"/>
+            <a:pPr indent="0" marL="0">
+              <a:buNone/>
+            </a:pPr>
+            <a:r>
+              <a:rPr lang="en-US" sz="1500" dirty="0">
+                <a:solidFill>
+                  <a:srgbClr val="FFFFFF"/>
+                </a:solidFill>
+              </a:rPr>
+              <a:t>BDEFs de projeção expondo só o que cada app usa</a:t>
+            </a:r>
+            <a:endParaRPr lang="en-US" sz="1500" dirty="0"/>
           </a:p>
         </p:txBody>
       </p:sp>
       <p:sp>
         <p:nvSpPr>
-          <p:cNvPr id="5" name="Decoração 1"/>
+          <p:cNvPr id="10" name="Marcador"/>
           <p:cNvSpPr/>
           <p:nvPr/>
         </p:nvSpPr>
         <p:spPr>
           <a:xfrm>
-            <a:off x="8503920" y="-1463040"/>
-            <a:ext cx="5120640" cy="5120640"/>
-          </a:xfrm>
-          <a:prstGeom prst="ellipse">
+            <a:off x="731520" y="3063240"/>
+            <a:ext cx="457200" cy="457200"/>
+          </a:xfrm>
+          <a:prstGeom prst="roundRect">
+            <a:avLst>
+              <a:gd name="adj" fmla="val 22000"/>
+            </a:avLst>
+          </a:prstGeom>
+          <a:solidFill>
+            <a:schemeClr val="accent1"/>
+          </a:solidFill>
+          <a:ln/>
+        </p:spPr>
+      </p:sp>
+      <p:pic>
+        <p:nvPicPr>
+          <p:cNvPr id="11" name="Image 2" descr="concluído">    </p:cNvPr>
+          <p:cNvPicPr>
+            <a:picLocks noChangeAspect="1"/>
+          </p:cNvPicPr>
+          <p:nvPr/>
+        </p:nvPicPr>
+        <p:blipFill>
+          <a:blip r:embed="rId102"/>
+          <a:stretch>
+            <a:fillRect/>
+          </a:stretch>
+        </p:blipFill>
+        <p:spPr>
+          <a:xfrm>
+            <a:off x="832104" y="3163824"/>
+            <a:ext cx="256032" cy="256032"/>
+          </a:xfrm>
+          <a:prstGeom prst="rect">
             <a:avLst/>
           </a:prstGeom>
+        </p:spPr>
+      </p:pic>
+      <p:sp>
+        <p:nvSpPr>
+          <p:cNvPr id="12" name="Text 7"/>
+          <p:cNvSpPr txBox="1"/>
+          <p:nvPr/>
+        </p:nvSpPr>
+        <p:spPr>
+          <a:xfrm>
+            <a:off x="1371600" y="2990088"/>
+            <a:ext cx="4526280" cy="777240"/>
+          </a:xfrm>
+          <a:prstGeom prst="rect">
+            <a:avLst/>
+          </a:prstGeom>
+          <a:noFill/>
+          <a:ln/>
+        </p:spPr>
+        <p:txBody>
+          <a:bodyPr wrap="square" lIns="0" tIns="0" rIns="0" bIns="0" rtlCol="0" anchor="t"/>
+          <a:lstStyle/>
+          <a:p>
+            <a:pPr indent="0" marL="0">
+              <a:buNone/>
+            </a:pPr>
+            <a:r>
+              <a:rPr lang="en-US" sz="1500" dirty="0">
+                <a:solidFill>
+                  <a:srgbClr val="FFFFFF"/>
+                </a:solidFill>
+              </a:rPr>
+              <a:t>Objetos ZPC_ADMIN e ZPC_PEDIDO, com a atividade 16</a:t>
+            </a:r>
+            <a:endParaRPr lang="en-US" sz="1500" dirty="0"/>
+          </a:p>
+        </p:txBody>
+      </p:sp>
+      <p:sp>
+        <p:nvSpPr>
+          <p:cNvPr id="13" name="Marcador"/>
+          <p:cNvSpPr/>
+          <p:nvPr/>
+        </p:nvSpPr>
+        <p:spPr>
+          <a:xfrm>
+            <a:off x="6263640" y="3063240"/>
+            <a:ext cx="457200" cy="457200"/>
+          </a:xfrm>
+          <a:prstGeom prst="roundRect">
+            <a:avLst>
+              <a:gd name="adj" fmla="val 22000"/>
+            </a:avLst>
+          </a:prstGeom>
           <a:solidFill>
-            <a:srgbClr val="0070F2">
-              <a:alpha val="28000"/>
-            </a:srgbClr>
+            <a:schemeClr val="accent1"/>
           </a:solidFill>
           <a:ln/>
         </p:spPr>
       </p:sp>
-      <p:sp>
-        <p:nvSpPr>
-          <p:cNvPr id="6" name="Decoração 2"/>
+      <p:pic>
+        <p:nvPicPr>
+          <p:cNvPr id="14" name="Image 3" descr="concluído">    </p:cNvPr>
+          <p:cNvPicPr>
+            <a:picLocks noChangeAspect="1"/>
+          </p:cNvPicPr>
+          <p:nvPr/>
+        </p:nvPicPr>
+        <p:blipFill>
+          <a:blip r:embed="rId103"/>
+          <a:stretch>
+            <a:fillRect/>
+          </a:stretch>
+        </p:blipFill>
+        <p:spPr>
+          <a:xfrm>
+            <a:off x="6364224" y="3163824"/>
+            <a:ext cx="256032" cy="256032"/>
+          </a:xfrm>
+          <a:prstGeom prst="rect">
+            <a:avLst/>
+          </a:prstGeom>
+        </p:spPr>
+      </p:pic>
+      <p:sp>
+        <p:nvSpPr>
+          <p:cNvPr id="15" name="Text 9"/>
+          <p:cNvSpPr txBox="1"/>
+          <p:nvPr/>
+        </p:nvSpPr>
+        <p:spPr>
+          <a:xfrm>
+            <a:off x="6903720" y="2990088"/>
+            <a:ext cx="4526280" cy="777240"/>
+          </a:xfrm>
+          <a:prstGeom prst="rect">
+            <a:avLst/>
+          </a:prstGeom>
+          <a:noFill/>
+          <a:ln/>
+        </p:spPr>
+        <p:txBody>
+          <a:bodyPr wrap="square" lIns="0" tIns="0" rIns="0" bIns="0" rtlCol="0" anchor="t"/>
+          <a:lstStyle/>
+          <a:p>
+            <a:pPr indent="0" marL="0">
+              <a:buNone/>
+            </a:pPr>
+            <a:r>
+              <a:rPr lang="en-US" sz="1500" dirty="0">
+                <a:solidFill>
+                  <a:srgbClr val="FFFFFF"/>
+                </a:solidFill>
+              </a:rPr>
+              <a:t>SAP BTP: IAM Apps, Business Catalogs e Business Roles</a:t>
+            </a:r>
+            <a:endParaRPr lang="en-US" sz="1500" dirty="0"/>
+          </a:p>
+        </p:txBody>
+      </p:sp>
+      <p:sp>
+        <p:nvSpPr>
+          <p:cNvPr id="16" name="Marcador"/>
           <p:cNvSpPr/>
           <p:nvPr/>
         </p:nvSpPr>
         <p:spPr>
           <a:xfrm>
-            <a:off x="9784080" y="1828800"/>
-            <a:ext cx="2834640" cy="2834640"/>
-          </a:xfrm>
-          <a:prstGeom prst="ellipse">
+            <a:off x="731520" y="4023360"/>
+            <a:ext cx="457200" cy="457200"/>
+          </a:xfrm>
+          <a:prstGeom prst="roundRect">
+            <a:avLst>
+              <a:gd name="adj" fmla="val 22000"/>
+            </a:avLst>
+          </a:prstGeom>
+          <a:solidFill>
+            <a:schemeClr val="accent1"/>
+          </a:solidFill>
+          <a:ln/>
+        </p:spPr>
+      </p:sp>
+      <p:pic>
+        <p:nvPicPr>
+          <p:cNvPr id="17" name="Image 4" descr="concluído">    </p:cNvPr>
+          <p:cNvPicPr>
+            <a:picLocks noChangeAspect="1"/>
+          </p:cNvPicPr>
+          <p:nvPr/>
+        </p:nvPicPr>
+        <p:blipFill>
+          <a:blip r:embed="rId104"/>
+          <a:stretch>
+            <a:fillRect/>
+          </a:stretch>
+        </p:blipFill>
+        <p:spPr>
+          <a:xfrm>
+            <a:off x="832104" y="4123944"/>
+            <a:ext cx="256032" cy="256032"/>
+          </a:xfrm>
+          <a:prstGeom prst="rect">
             <a:avLst/>
           </a:prstGeom>
+        </p:spPr>
+      </p:pic>
+      <p:sp>
+        <p:nvSpPr>
+          <p:cNvPr id="18" name="Text 11"/>
+          <p:cNvSpPr txBox="1"/>
+          <p:nvPr/>
+        </p:nvSpPr>
+        <p:spPr>
+          <a:xfrm>
+            <a:off x="1371600" y="3950208"/>
+            <a:ext cx="4526280" cy="777240"/>
+          </a:xfrm>
+          <a:prstGeom prst="rect">
+            <a:avLst/>
+          </a:prstGeom>
+          <a:noFill/>
+          <a:ln/>
+        </p:spPr>
+        <p:txBody>
+          <a:bodyPr wrap="square" lIns="0" tIns="0" rIns="0" bIns="0" rtlCol="0" anchor="t"/>
+          <a:lstStyle/>
+          <a:p>
+            <a:pPr indent="0" marL="0">
+              <a:buNone/>
+            </a:pPr>
+            <a:r>
+              <a:rPr lang="en-US" sz="1500" dirty="0">
+                <a:solidFill>
+                  <a:srgbClr val="FFFFFF"/>
+                </a:solidFill>
+              </a:rPr>
+              <a:t>On-Premise: SU21, SU24, roles PFCG e S_START no SAP GUI</a:t>
+            </a:r>
+            <a:endParaRPr lang="en-US" sz="1500" dirty="0"/>
+          </a:p>
+        </p:txBody>
+      </p:sp>
+      <p:sp>
+        <p:nvSpPr>
+          <p:cNvPr id="19" name="Marcador"/>
+          <p:cNvSpPr/>
+          <p:nvPr/>
+        </p:nvSpPr>
+        <p:spPr>
+          <a:xfrm>
+            <a:off x="6263640" y="4023360"/>
+            <a:ext cx="457200" cy="457200"/>
+          </a:xfrm>
+          <a:prstGeom prst="roundRect">
+            <a:avLst>
+              <a:gd name="adj" fmla="val 22000"/>
+            </a:avLst>
+          </a:prstGeom>
           <a:solidFill>
-            <a:srgbClr val="4DB1FF">
-              <a:alpha val="18000"/>
-            </a:srgbClr>
+            <a:schemeClr val="accent1"/>
           </a:solidFill>
           <a:ln/>
         </p:spPr>
       </p:sp>
-      <p:sp>
-        <p:nvSpPr>
-          <p:cNvPr id="7" name="Shape 5"/>
+      <p:pic>
+        <p:nvPicPr>
+          <p:cNvPr id="20" name="Image 5" descr="concluído">    </p:cNvPr>
+          <p:cNvPicPr>
+            <a:picLocks noChangeAspect="1"/>
+          </p:cNvPicPr>
+          <p:nvPr/>
+        </p:nvPicPr>
+        <p:blipFill>
+          <a:blip r:embed="rId105"/>
+          <a:stretch>
+            <a:fillRect/>
+          </a:stretch>
+        </p:blipFill>
+        <p:spPr>
+          <a:xfrm>
+            <a:off x="6364224" y="4123944"/>
+            <a:ext cx="256032" cy="256032"/>
+          </a:xfrm>
+          <a:prstGeom prst="rect">
+            <a:avLst/>
+          </a:prstGeom>
+        </p:spPr>
+      </p:pic>
+      <p:sp>
+        <p:nvSpPr>
+          <p:cNvPr id="21" name="Text 13"/>
+          <p:cNvSpPr txBox="1"/>
+          <p:nvPr/>
+        </p:nvSpPr>
+        <p:spPr>
+          <a:xfrm>
+            <a:off x="6903720" y="3950208"/>
+            <a:ext cx="4526280" cy="777240"/>
+          </a:xfrm>
+          <a:prstGeom prst="rect">
+            <a:avLst/>
+          </a:prstGeom>
+          <a:noFill/>
+          <a:ln/>
+        </p:spPr>
+        <p:txBody>
+          <a:bodyPr wrap="square" lIns="0" tIns="0" rIns="0" bIns="0" rtlCol="0" anchor="t"/>
+          <a:lstStyle/>
+          <a:p>
+            <a:pPr indent="0" marL="0">
+              <a:buNone/>
+            </a:pPr>
+            <a:r>
+              <a:rPr lang="en-US" sz="1500" dirty="0">
+                <a:solidFill>
+                  <a:srgbClr val="FFFFFF"/>
+                </a:solidFill>
+              </a:rPr>
+              <a:t>Dados de demonstração e cenários testados no preview</a:t>
+            </a:r>
+            <a:endParaRPr lang="en-US" sz="1500" dirty="0"/>
+          </a:p>
+        </p:txBody>
+      </p:sp>
+      <p:sp>
+        <p:nvSpPr>
+          <p:cNvPr id="22" name="Próxima etapa"/>
           <p:cNvSpPr/>
           <p:nvPr/>
         </p:nvSpPr>
         <p:spPr>
           <a:xfrm>
-            <a:off x="923544" y="5266944"/>
-            <a:ext cx="10131552" cy="0"/>
-          </a:xfrm>
-          <a:prstGeom prst="line">
+            <a:off x="731520" y="5394960"/>
+            <a:ext cx="10725912" cy="777240"/>
+          </a:xfrm>
+          <a:prstGeom prst="roundRect">
+            <a:avLst>
+              <a:gd name="adj" fmla="val 16471"/>
+            </a:avLst>
+          </a:prstGeom>
+          <a:solidFill>
+            <a:srgbClr val="1B3A7A"/>
+          </a:solidFill>
+          <a:ln/>
+        </p:spPr>
+      </p:sp>
+      <p:pic>
+        <p:nvPicPr>
+          <p:cNvPr id="23" name="Image 6" descr="próxima etapa">    </p:cNvPr>
+          <p:cNvPicPr>
+            <a:picLocks noChangeAspect="1"/>
+          </p:cNvPicPr>
+          <p:nvPr/>
+        </p:nvPicPr>
+        <p:blipFill>
+          <a:blip r:embed="rId106"/>
+          <a:stretch>
+            <a:fillRect/>
+          </a:stretch>
+        </p:blipFill>
+        <p:spPr>
+          <a:xfrm>
+            <a:off x="960120" y="5559552"/>
+            <a:ext cx="438912" cy="438912"/>
+          </a:xfrm>
+          <a:prstGeom prst="rect">
             <a:avLst/>
           </a:prstGeom>
+        </p:spPr>
+      </p:pic>
+      <p:sp>
+        <p:nvSpPr>
+          <p:cNvPr id="24" name="Text 15"/>
+          <p:cNvSpPr txBox="1"/>
+          <p:nvPr/>
+        </p:nvSpPr>
+        <p:spPr>
+          <a:xfrm>
+            <a:off x="1600200" y="5440680"/>
+            <a:ext cx="9692640" cy="685800"/>
+          </a:xfrm>
+          <a:prstGeom prst="rect">
+            <a:avLst/>
+          </a:prstGeom>
           <a:noFill/>
-          <a:ln w="25400">
-            <a:solidFill>
-              <a:srgbClr val="3A4654"/>
-            </a:solidFill>
-            <a:prstDash val="solid"/>
-          </a:ln>
-        </p:spPr>
-      </p:sp>
-      <p:sp>
-        <p:nvSpPr>
-          <p:cNvPr id="8" name="Etapa 1"/>
-          <p:cNvSpPr/>
-          <p:nvPr/>
-        </p:nvSpPr>
-        <p:spPr>
-          <a:xfrm>
-            <a:off x="731520" y="5074920"/>
-            <a:ext cx="384048" cy="384048"/>
-          </a:xfrm>
-          <a:prstGeom prst="ellipse">
-            <a:avLst/>
-          </a:prstGeom>
-          <a:solidFill>
-            <a:srgbClr val="1F4F86"/>
-          </a:solidFill>
-          <a:ln w="19050">
-            <a:solidFill>
-              <a:srgbClr val="1F4F86"/>
-            </a:solidFill>
-          </a:ln>
+          <a:ln/>
         </p:spPr>
         <p:txBody>
           <a:bodyPr wrap="square" lIns="0" tIns="0" rIns="0" bIns="0" rtlCol="0" anchor="ctr"/>
           <a:lstStyle/>
           <a:p>
-            <a:pPr algn="ctr" indent="0" marL="0">
-              <a:buNone/>
-            </a:pPr>
-            <a:r>
-              <a:rPr lang="en-US" sz="1300" b="1" dirty="0">
+            <a:pPr indent="0" marL="0">
+              <a:buNone/>
+            </a:pPr>
+            <a:r>
+              <a:rPr lang="en-US" sz="1600" b="1" dirty="0">
+                <a:solidFill>
+                  <a:srgbClr val="89D1FF"/>
+                </a:solidFill>
+              </a:rPr>
+              <a:t>Próxima etapa ·  </a:t>
+            </a:r>
+            <a:pPr indent="0" marL="0">
+              <a:buNone/>
+            </a:pPr>
+            <a:r>
+              <a:rPr lang="en-US" sz="1600" dirty="0">
                 <a:solidFill>
                   <a:srgbClr val="FFFFFF"/>
                 </a:solidFill>
               </a:rPr>
-              <a:t>1</a:t>
-            </a:r>
-            <a:endParaRPr lang="en-US" sz="1300" dirty="0"/>
+              <a:t>Apps Fiori: gerar, navegar e implantar.</a:t>
+            </a:r>
+            <a:endParaRPr lang="en-US" sz="1600" dirty="0"/>
           </a:p>
         </p:txBody>
       </p:sp>
       <p:sp>
         <p:nvSpPr>
-          <p:cNvPr id="9" name="Text 7"/>
+          <p:cNvPr id="40" name="Rodapé"/>
           <p:cNvSpPr txBox="1"/>
           <p:nvPr/>
         </p:nvSpPr>
         <p:spPr>
           <a:xfrm>
-            <a:off x="192024" y="5550408"/>
-            <a:ext cx="1463040" cy="274320"/>
+            <a:off x="731520" y="6419088"/>
+            <a:ext cx="9144000" cy="320040"/>
           </a:xfrm>
           <a:prstGeom prst="rect">
             <a:avLst/>
           </a:prstGeom>
           <a:noFill/>
-          <a:ln/>
-        </p:spPr>
-        <p:txBody>
-          <a:bodyPr wrap="square" lIns="0" tIns="0" rIns="0" bIns="0" rtlCol="0" anchor="ctr"/>
-          <a:lstStyle/>
-          <a:p>
-            <a:pPr algn="ctr" indent="0" marL="0">
-              <a:buNone/>
-            </a:pPr>
-            <a:r>
-              <a:rPr lang="en-US" sz="1100" dirty="0">
-                <a:solidFill>
-                  <a:srgbClr val="A9B4BE"/>
-                </a:solidFill>
-              </a:rPr>
-              <a:t>Modelagem de dados</a:t>
-            </a:r>
-            <a:endParaRPr lang="en-US" sz="1100" dirty="0"/>
-          </a:p>
-        </p:txBody>
-      </p:sp>
-      <p:sp>
-        <p:nvSpPr>
-          <p:cNvPr id="10" name="Etapa 2"/>
-          <p:cNvSpPr/>
-          <p:nvPr/>
-        </p:nvSpPr>
-        <p:spPr>
-          <a:xfrm>
-            <a:off x="3264408" y="5074920"/>
-            <a:ext cx="384048" cy="384048"/>
-          </a:xfrm>
-          <a:prstGeom prst="ellipse">
-            <a:avLst/>
-          </a:prstGeom>
-          <a:solidFill>
-            <a:srgbClr val="1F4F86"/>
-          </a:solidFill>
-          <a:ln w="19050">
-            <a:solidFill>
-              <a:srgbClr val="1F4F86"/>
-            </a:solidFill>
-          </a:ln>
-        </p:spPr>
-        <p:txBody>
-          <a:bodyPr wrap="square" lIns="0" tIns="0" rIns="0" bIns="0" rtlCol="0" anchor="ctr"/>
-          <a:lstStyle/>
-          <a:p>
-            <a:pPr algn="ctr" indent="0" marL="0">
-              <a:buNone/>
-            </a:pPr>
-            <a:r>
-              <a:rPr lang="en-US" sz="1300" b="1" dirty="0">
-                <a:solidFill>
-                  <a:srgbClr val="FFFFFF"/>
-                </a:solidFill>
-              </a:rPr>
-              <a:t>2</a:t>
-            </a:r>
-            <a:endParaRPr lang="en-US" sz="1300" dirty="0"/>
-          </a:p>
-        </p:txBody>
-      </p:sp>
-      <p:sp>
-        <p:nvSpPr>
-          <p:cNvPr id="11" name="Text 9"/>
-          <p:cNvSpPr txBox="1"/>
-          <p:nvPr/>
-        </p:nvSpPr>
-        <p:spPr>
-          <a:xfrm>
-            <a:off x="2724912" y="5550408"/>
-            <a:ext cx="1463040" cy="274320"/>
-          </a:xfrm>
-          <a:prstGeom prst="rect">
-            <a:avLst/>
-          </a:prstGeom>
-          <a:noFill/>
-          <a:ln/>
-        </p:spPr>
-        <p:txBody>
-          <a:bodyPr wrap="square" lIns="0" tIns="0" rIns="0" bIns="0" rtlCol="0" anchor="ctr"/>
-          <a:lstStyle/>
-          <a:p>
-            <a:pPr algn="ctr" indent="0" marL="0">
-              <a:buNone/>
-            </a:pPr>
-            <a:r>
-              <a:rPr lang="en-US" sz="1100" dirty="0">
-                <a:solidFill>
-                  <a:srgbClr val="A9B4BE"/>
-                </a:solidFill>
-              </a:rPr>
-              <a:t>Core Data Services</a:t>
-            </a:r>
-            <a:endParaRPr lang="en-US" sz="1100" dirty="0"/>
-          </a:p>
-        </p:txBody>
-      </p:sp>
-      <p:sp>
-        <p:nvSpPr>
-          <p:cNvPr id="12" name="Etapa 3"/>
-          <p:cNvSpPr/>
-          <p:nvPr/>
-        </p:nvSpPr>
-        <p:spPr>
-          <a:xfrm>
-            <a:off x="5797296" y="5074920"/>
-            <a:ext cx="384048" cy="384048"/>
-          </a:xfrm>
-          <a:prstGeom prst="ellipse">
-            <a:avLst/>
-          </a:prstGeom>
-          <a:solidFill>
-            <a:srgbClr val="1F4F86"/>
-          </a:solidFill>
-          <a:ln w="19050">
-            <a:solidFill>
-              <a:srgbClr val="1F4F86"/>
-            </a:solidFill>
-          </a:ln>
-        </p:spPr>
-        <p:txBody>
-          <a:bodyPr wrap="square" lIns="0" tIns="0" rIns="0" bIns="0" rtlCol="0" anchor="ctr"/>
-          <a:lstStyle/>
-          <a:p>
-            <a:pPr algn="ctr" indent="0" marL="0">
-              <a:buNone/>
-            </a:pPr>
-            <a:r>
-              <a:rPr lang="en-US" sz="1300" b="1" dirty="0">
-                <a:solidFill>
-                  <a:srgbClr val="FFFFFF"/>
-                </a:solidFill>
-              </a:rPr>
-              <a:t>3</a:t>
-            </a:r>
-            <a:endParaRPr lang="en-US" sz="1300" dirty="0"/>
-          </a:p>
-        </p:txBody>
-      </p:sp>
-      <p:sp>
-        <p:nvSpPr>
-          <p:cNvPr id="13" name="Text 11"/>
-          <p:cNvSpPr txBox="1"/>
-          <p:nvPr/>
-        </p:nvSpPr>
-        <p:spPr>
-          <a:xfrm>
-            <a:off x="5257800" y="5550408"/>
-            <a:ext cx="1463040" cy="274320"/>
-          </a:xfrm>
-          <a:prstGeom prst="rect">
-            <a:avLst/>
-          </a:prstGeom>
-          <a:noFill/>
-          <a:ln/>
-        </p:spPr>
-        <p:txBody>
-          <a:bodyPr wrap="square" lIns="0" tIns="0" rIns="0" bIns="0" rtlCol="0" anchor="ctr"/>
-          <a:lstStyle/>
-          <a:p>
-            <a:pPr algn="ctr" indent="0" marL="0">
-              <a:buNone/>
-            </a:pPr>
-            <a:r>
-              <a:rPr lang="en-US" sz="1100" dirty="0">
-                <a:solidFill>
-                  <a:srgbClr val="A9B4BE"/>
-                </a:solidFill>
-              </a:rPr>
-              <a:t>Comportamento RAP</a:t>
-            </a:r>
-            <a:endParaRPr lang="en-US" sz="1100" dirty="0"/>
-          </a:p>
-        </p:txBody>
-      </p:sp>
-      <p:sp>
-        <p:nvSpPr>
-          <p:cNvPr id="14" name="Etapa 4"/>
-          <p:cNvSpPr/>
-          <p:nvPr/>
-        </p:nvSpPr>
-        <p:spPr>
-          <a:xfrm>
-            <a:off x="8330184" y="5074920"/>
-            <a:ext cx="384048" cy="384048"/>
-          </a:xfrm>
-          <a:prstGeom prst="ellipse">
-            <a:avLst/>
-          </a:prstGeom>
-          <a:solidFill>
-            <a:srgbClr val="1F4F86"/>
-          </a:solidFill>
-          <a:ln w="19050">
-            <a:solidFill>
-              <a:srgbClr val="1F4F86"/>
-            </a:solidFill>
-          </a:ln>
-        </p:spPr>
-        <p:txBody>
-          <a:bodyPr wrap="square" lIns="0" tIns="0" rIns="0" bIns="0" rtlCol="0" anchor="ctr"/>
-          <a:lstStyle/>
-          <a:p>
-            <a:pPr algn="ctr" indent="0" marL="0">
-              <a:buNone/>
-            </a:pPr>
-            <a:r>
-              <a:rPr lang="en-US" sz="1300" b="1" dirty="0">
-                <a:solidFill>
-                  <a:srgbClr val="FFFFFF"/>
-                </a:solidFill>
-              </a:rPr>
-              <a:t>4</a:t>
-            </a:r>
-            <a:endParaRPr lang="en-US" sz="1300" dirty="0"/>
-          </a:p>
-        </p:txBody>
-      </p:sp>
-      <p:sp>
-        <p:nvSpPr>
-          <p:cNvPr id="15" name="Text 13"/>
-          <p:cNvSpPr txBox="1"/>
-          <p:nvPr/>
-        </p:nvSpPr>
-        <p:spPr>
-          <a:xfrm>
-            <a:off x="7790688" y="5550408"/>
-            <a:ext cx="1463040" cy="274320"/>
-          </a:xfrm>
-          <a:prstGeom prst="rect">
-            <a:avLst/>
-          </a:prstGeom>
-          <a:noFill/>
-          <a:ln/>
-        </p:spPr>
-        <p:txBody>
-          <a:bodyPr wrap="square" lIns="0" tIns="0" rIns="0" bIns="0" rtlCol="0" anchor="ctr"/>
-          <a:lstStyle/>
-          <a:p>
-            <a:pPr algn="ctr" indent="0" marL="0">
-              <a:buNone/>
-            </a:pPr>
-            <a:r>
-              <a:rPr lang="en-US" sz="1100" dirty="0">
-                <a:solidFill>
-                  <a:srgbClr val="A9B4BE"/>
-                </a:solidFill>
-              </a:rPr>
-              <a:t>Serviços OData</a:t>
-            </a:r>
-            <a:endParaRPr lang="en-US" sz="1100" dirty="0"/>
-          </a:p>
-        </p:txBody>
-      </p:sp>
-      <p:sp>
-        <p:nvSpPr>
-          <p:cNvPr id="16" name="Etapa 5"/>
-          <p:cNvSpPr/>
-          <p:nvPr/>
-        </p:nvSpPr>
-        <p:spPr>
-          <a:xfrm>
-            <a:off x="10863072" y="5074920"/>
-            <a:ext cx="384048" cy="384048"/>
-          </a:xfrm>
-          <a:prstGeom prst="ellipse">
-            <a:avLst/>
-          </a:prstGeom>
-          <a:solidFill>
-            <a:srgbClr val="1D232A"/>
-          </a:solidFill>
-          <a:ln w="19050">
-            <a:solidFill>
-              <a:srgbClr val="3A4654"/>
-            </a:solidFill>
-          </a:ln>
-        </p:spPr>
-        <p:txBody>
-          <a:bodyPr wrap="square" lIns="0" tIns="0" rIns="0" bIns="0" rtlCol="0" anchor="ctr"/>
-          <a:lstStyle/>
-          <a:p>
-            <a:pPr algn="ctr" indent="0" marL="0">
-              <a:buNone/>
-            </a:pPr>
-            <a:r>
-              <a:rPr lang="en-US" sz="1300" b="1" dirty="0">
-                <a:solidFill>
-                  <a:srgbClr val="A9B4BE"/>
-                </a:solidFill>
-              </a:rPr>
-              <a:t>5</a:t>
-            </a:r>
-            <a:endParaRPr lang="en-US" sz="1300" dirty="0"/>
-          </a:p>
-        </p:txBody>
-      </p:sp>
-      <p:sp>
-        <p:nvSpPr>
-          <p:cNvPr id="17" name="Text 15"/>
-          <p:cNvSpPr txBox="1"/>
-          <p:nvPr/>
-        </p:nvSpPr>
-        <p:spPr>
-          <a:xfrm>
-            <a:off x="10323576" y="5550408"/>
-            <a:ext cx="1463040" cy="274320"/>
-          </a:xfrm>
-          <a:prstGeom prst="rect">
-            <a:avLst/>
-          </a:prstGeom>
-          <a:noFill/>
-          <a:ln/>
-        </p:spPr>
-        <p:txBody>
-          <a:bodyPr wrap="square" lIns="0" tIns="0" rIns="0" bIns="0" rtlCol="0" anchor="ctr"/>
-          <a:lstStyle/>
-          <a:p>
-            <a:pPr algn="ctr" indent="0" marL="0">
-              <a:buNone/>
-            </a:pPr>
-            <a:r>
-              <a:rPr lang="en-US" sz="1100" dirty="0">
-                <a:solidFill>
-                  <a:srgbClr val="A9B4BE"/>
-                </a:solidFill>
-              </a:rPr>
-              <a:t>Apps Fiori</a:t>
-            </a:r>
-            <a:endParaRPr lang="en-US" sz="1100" dirty="0"/>
-          </a:p>
-        </p:txBody>
-      </p:sp>
-      <p:sp>
-        <p:nvSpPr>
-          <p:cNvPr id="18" name="Próxima etapa"/>
-          <p:cNvSpPr/>
-          <p:nvPr/>
-        </p:nvSpPr>
-        <p:spPr>
-          <a:xfrm>
-            <a:off x="8183880" y="1783080"/>
-            <a:ext cx="3429000" cy="1600200"/>
-          </a:xfrm>
-          <a:prstGeom prst="roundRect">
-            <a:avLst>
-              <a:gd name="adj" fmla="val 6857"/>
-            </a:avLst>
-          </a:prstGeom>
-          <a:solidFill>
-            <a:srgbClr val="1D232A"/>
-          </a:solidFill>
-          <a:ln/>
-        </p:spPr>
-      </p:sp>
-      <p:sp>
-        <p:nvSpPr>
-          <p:cNvPr id="19" name="Text 17"/>
-          <p:cNvSpPr txBox="1"/>
-          <p:nvPr/>
-        </p:nvSpPr>
-        <p:spPr>
-          <a:xfrm>
-            <a:off x="8412480" y="1965960"/>
-            <a:ext cx="3017520" cy="274320"/>
-          </a:xfrm>
-          <a:prstGeom prst="rect">
-            <a:avLst/>
-          </a:prstGeom>
-          <a:noFill/>
-          <a:ln/>
-        </p:spPr>
-        <p:txBody>
-          <a:bodyPr wrap="square" lIns="0" tIns="0" rIns="0" bIns="0" rtlCol="0" anchor="ctr"/>
-          <a:lstStyle/>
-          <a:p>
-            <a:pPr indent="0" marL="0">
-              <a:buNone/>
-            </a:pPr>
-            <a:r>
-              <a:rPr lang="en-US" sz="1100" b="1" spc="150" kern="0" dirty="0">
-                <a:solidFill>
-                  <a:srgbClr val="4DB1FF"/>
-                </a:solidFill>
-              </a:rPr>
-              <a:t>PRÓXIMA ETAPA</a:t>
-            </a:r>
-            <a:endParaRPr lang="en-US" sz="1100" dirty="0"/>
-          </a:p>
-        </p:txBody>
-      </p:sp>
-      <p:sp>
-        <p:nvSpPr>
-          <p:cNvPr id="20" name="Text 18"/>
-          <p:cNvSpPr txBox="1"/>
-          <p:nvPr/>
-        </p:nvSpPr>
-        <p:spPr>
-          <a:xfrm>
-            <a:off x="8412480" y="2286000"/>
-            <a:ext cx="3017520" cy="960120"/>
-          </a:xfrm>
-          <a:prstGeom prst="rect">
-            <a:avLst/>
-          </a:prstGeom>
-          <a:noFill/>
-          <a:ln/>
         </p:spPr>
         <p:txBody>
           <a:bodyPr wrap="square" lIns="0" tIns="0" rIns="0" bIns="0" rtlCol="0" anchor="t"/>
           <a:lstStyle/>
           <a:p>
-            <a:pPr indent="0" marL="0">
-              <a:buNone/>
-            </a:pPr>
-            <a:r>
-              <a:rPr lang="en-US" sz="1800" b="1" dirty="0">
-                <a:solidFill>
-                  <a:srgbClr val="FFFFFF"/>
-                </a:solidFill>
-              </a:rPr>
-              <a:t>Apps Fiori: gerar, navegar e implantar</a:t>
-            </a:r>
-            <a:endParaRPr lang="en-US" sz="1800" dirty="0"/>
+            <a:r>
+              <a:rPr lang="pt-BR" sz="1000" dirty="0">
+                <a:solidFill>
+                  <a:srgbClr val="89D1FF"/>
+                </a:solidFill>
+              </a:rPr>
+              <a:t>Pedidos de Compras · SAP RAP no BTP e On-Premise  ·  Etapa 4 de 5 — Serviços OData</a:t>
+            </a:r>
           </a:p>
         </p:txBody>
       </p:sp>
@@ -26729,7 +26368,7 @@
             <a:r>
               <a:rPr lang="en-US" sz="1400" b="1" spc="200" kern="0" dirty="0">
                 <a:solidFill>
-                  <a:schemeClr val="accent1"/>
+                  <a:srgbClr val="89D1FF"/>
                 </a:solidFill>
               </a:rPr>
               <a:t>ETAPA 4 · ON-PREMISE</a:t>
@@ -26816,50 +26455,6 @@
       </p:sp>
       <p:sp>
         <p:nvSpPr>
-          <p:cNvPr id="5" name="Decoração 1"/>
-          <p:cNvSpPr/>
-          <p:nvPr/>
-        </p:nvSpPr>
-        <p:spPr>
-          <a:xfrm>
-            <a:off x="8503920" y="-1463040"/>
-            <a:ext cx="5120640" cy="5120640"/>
-          </a:xfrm>
-          <a:prstGeom prst="ellipse">
-            <a:avLst/>
-          </a:prstGeom>
-          <a:solidFill>
-            <a:srgbClr val="0070F2">
-              <a:alpha val="28000"/>
-            </a:srgbClr>
-          </a:solidFill>
-          <a:ln/>
-        </p:spPr>
-      </p:sp>
-      <p:sp>
-        <p:nvSpPr>
-          <p:cNvPr id="6" name="Decoração 2"/>
-          <p:cNvSpPr/>
-          <p:nvPr/>
-        </p:nvSpPr>
-        <p:spPr>
-          <a:xfrm>
-            <a:off x="9784080" y="1828800"/>
-            <a:ext cx="2834640" cy="2834640"/>
-          </a:xfrm>
-          <a:prstGeom prst="ellipse">
-            <a:avLst/>
-          </a:prstGeom>
-          <a:solidFill>
-            <a:srgbClr val="4DB1FF">
-              <a:alpha val="18000"/>
-            </a:srgbClr>
-          </a:solidFill>
-          <a:ln/>
-        </p:spPr>
-      </p:sp>
-      <p:sp>
-        <p:nvSpPr>
           <p:cNvPr id="7" name="Ícone settings"/>
           <p:cNvSpPr/>
           <p:nvPr/>
@@ -26875,7 +26470,7 @@
             </a:avLst>
           </a:prstGeom>
           <a:solidFill>
-            <a:srgbClr val="1D232A"/>
+            <a:srgbClr val="1B3A7A"/>
           </a:solidFill>
           <a:ln/>
         </p:spPr>
@@ -26921,7 +26516,7 @@
             </a:avLst>
           </a:prstGeom>
           <a:solidFill>
-            <a:srgbClr val="1D232A"/>
+            <a:srgbClr val="1B3A7A"/>
           </a:solidFill>
           <a:ln/>
         </p:spPr>
@@ -26953,7 +26548,7 @@
             <a:r>
               <a:rPr lang="en-US" sz="1100" b="1" spc="150" kern="0" dirty="0">
                 <a:solidFill>
-                  <a:srgbClr val="4DB1FF"/>
+                  <a:srgbClr val="89D1FF"/>
                 </a:solidFill>
               </a:rPr>
               <a:t>OBJETOS NESTA SEÇÃO</a:t>
@@ -27003,7 +26598,7 @@
             <a:r>
               <a:rPr lang="en-US" sz="1100" dirty="0">
                 <a:solidFill>
-                  <a:srgbClr val="A9B4BE"/>
+                  <a:srgbClr val="D1EFFF"/>
                 </a:solidFill>
               </a:rPr>
               <a:t>  classe de objetos</a:t>
@@ -27053,7 +26648,7 @@
             <a:r>
               <a:rPr lang="en-US" sz="1100" dirty="0">
                 <a:solidFill>
-                  <a:srgbClr val="A9B4BE"/>
+                  <a:srgbClr val="D1EFFF"/>
                 </a:solidFill>
               </a:rPr>
               <a:t>  objetos</a:t>
@@ -27103,7 +26698,7 @@
             <a:r>
               <a:rPr lang="en-US" sz="1100" dirty="0">
                 <a:solidFill>
-                  <a:srgbClr val="A9B4BE"/>
+                  <a:srgbClr val="D1EFFF"/>
                 </a:solidFill>
               </a:rPr>
               <a:t>  grupos de serviços</a:t>
@@ -27153,7 +26748,7 @@
             <a:r>
               <a:rPr lang="en-US" sz="1100" dirty="0">
                 <a:solidFill>
-                  <a:srgbClr val="A9B4BE"/>
+                  <a:srgbClr val="D1EFFF"/>
                 </a:solidFill>
               </a:rPr>
               <a:t>  valores propostos (G4BA)</a:t>
@@ -27203,7 +26798,7 @@
             <a:r>
               <a:rPr lang="en-US" sz="1100" dirty="0">
                 <a:solidFill>
-                  <a:srgbClr val="A9B4BE"/>
+                  <a:srgbClr val="D1EFFF"/>
                 </a:solidFill>
               </a:rPr>
               <a:t>  roles PFCG</a:t>
@@ -27253,7 +26848,7 @@
             <a:r>
               <a:rPr lang="en-US" sz="1100" dirty="0">
                 <a:solidFill>
-                  <a:srgbClr val="A9B4BE"/>
+                  <a:srgbClr val="D1EFFF"/>
                 </a:solidFill>
               </a:rPr>
               <a:t>  acesso ao serviço OData V4</a:t>
@@ -27303,7 +26898,7 @@
             <a:r>
               <a:rPr lang="en-US" sz="1100" dirty="0">
                 <a:solidFill>
-                  <a:srgbClr val="A9B4BE"/>
+                  <a:srgbClr val="D1EFFF"/>
                 </a:solidFill>
               </a:rPr>
               <a:t>  diagnóstico</a:t>
@@ -41571,7 +41166,7 @@
             <a:r>
               <a:rPr lang="en-US" sz="1400" b="1" spc="200" kern="0" dirty="0">
                 <a:solidFill>
-                  <a:schemeClr val="accent1"/>
+                  <a:srgbClr val="89D1FF"/>
                 </a:solidFill>
               </a:rPr>
               <a:t>ETAPA 4 · COMMON</a:t>
@@ -41658,50 +41253,6 @@
       </p:sp>
       <p:sp>
         <p:nvSpPr>
-          <p:cNvPr id="5" name="Decoração 1"/>
-          <p:cNvSpPr/>
-          <p:nvPr/>
-        </p:nvSpPr>
-        <p:spPr>
-          <a:xfrm>
-            <a:off x="8503920" y="-1463040"/>
-            <a:ext cx="5120640" cy="5120640"/>
-          </a:xfrm>
-          <a:prstGeom prst="ellipse">
-            <a:avLst/>
-          </a:prstGeom>
-          <a:solidFill>
-            <a:srgbClr val="0070F2">
-              <a:alpha val="28000"/>
-            </a:srgbClr>
-          </a:solidFill>
-          <a:ln/>
-        </p:spPr>
-      </p:sp>
-      <p:sp>
-        <p:nvSpPr>
-          <p:cNvPr id="6" name="Decoração 2"/>
-          <p:cNvSpPr/>
-          <p:nvPr/>
-        </p:nvSpPr>
-        <p:spPr>
-          <a:xfrm>
-            <a:off x="9784080" y="1828800"/>
-            <a:ext cx="2834640" cy="2834640"/>
-          </a:xfrm>
-          <a:prstGeom prst="ellipse">
-            <a:avLst/>
-          </a:prstGeom>
-          <a:solidFill>
-            <a:srgbClr val="4DB1FF">
-              <a:alpha val="18000"/>
-            </a:srgbClr>
-          </a:solidFill>
-          <a:ln/>
-        </p:spPr>
-      </p:sp>
-      <p:sp>
-        <p:nvSpPr>
           <p:cNvPr id="7" name="Ícone settings"/>
           <p:cNvSpPr/>
           <p:nvPr/>
@@ -41717,7 +41268,7 @@
             </a:avLst>
           </a:prstGeom>
           <a:solidFill>
-            <a:srgbClr val="1D232A"/>
+            <a:srgbClr val="1B3A7A"/>
           </a:solidFill>
           <a:ln/>
         </p:spPr>
@@ -41763,7 +41314,7 @@
             </a:avLst>
           </a:prstGeom>
           <a:solidFill>
-            <a:srgbClr val="1D232A"/>
+            <a:srgbClr val="1B3A7A"/>
           </a:solidFill>
           <a:ln/>
         </p:spPr>
@@ -41795,7 +41346,7 @@
             <a:r>
               <a:rPr lang="en-US" sz="1100" b="1" spc="150" kern="0" dirty="0">
                 <a:solidFill>
-                  <a:srgbClr val="4DB1FF"/>
+                  <a:srgbClr val="89D1FF"/>
                 </a:solidFill>
               </a:rPr>
               <a:t>OBJETOS NESTA SEÇÃO</a:t>
@@ -41845,7 +41396,7 @@
             <a:r>
               <a:rPr lang="en-US" sz="1100" dirty="0">
                 <a:solidFill>
-                  <a:srgbClr val="A9B4BE"/>
+                  <a:srgbClr val="D1EFFF"/>
                 </a:solidFill>
               </a:rPr>
               <a:t>  authorization object</a:t>
@@ -41895,7 +41446,7 @@
             <a:r>
               <a:rPr lang="en-US" sz="1100" dirty="0">
                 <a:solidFill>
-                  <a:srgbClr val="A9B4BE"/>
+                  <a:srgbClr val="D1EFFF"/>
                 </a:solidFill>
               </a:rPr>
               <a:t>  authorization object</a:t>
@@ -41945,7 +41496,7 @@
             <a:r>
               <a:rPr lang="en-US" sz="1100" dirty="0">
                 <a:solidFill>
-                  <a:srgbClr val="A9B4BE"/>
+                  <a:srgbClr val="D1EFFF"/>
                 </a:solidFill>
               </a:rPr>
               <a:t>  IAM Apps</a:t>
@@ -41995,7 +41546,7 @@
             <a:r>
               <a:rPr lang="en-US" sz="1100" dirty="0">
                 <a:solidFill>
-                  <a:srgbClr val="A9B4BE"/>
+                  <a:srgbClr val="D1EFFF"/>
                 </a:solidFill>
               </a:rPr>
               <a:t>  Business Catalogs</a:t>
@@ -42045,7 +41596,7 @@
             <a:r>
               <a:rPr lang="en-US" sz="1100" dirty="0">
                 <a:solidFill>
-                  <a:srgbClr val="A9B4BE"/>
+                  <a:srgbClr val="D1EFFF"/>
                 </a:solidFill>
               </a:rPr>
               <a:t>  Business Roles</a:t>
@@ -42095,7 +41646,7 @@
             <a:r>
               <a:rPr lang="en-US" sz="1100" dirty="0">
                 <a:solidFill>
-                  <a:srgbClr val="A9B4BE"/>
+                  <a:srgbClr val="D1EFFF"/>
                 </a:solidFill>
               </a:rPr>
               <a:t>  service definition</a:t>
@@ -42145,7 +41696,7 @@
             <a:r>
               <a:rPr lang="en-US" sz="1100" dirty="0">
                 <a:solidFill>
-                  <a:srgbClr val="A9B4BE"/>
+                  <a:srgbClr val="D1EFFF"/>
                 </a:solidFill>
               </a:rPr>
               <a:t>  service binding</a:t>
@@ -45479,7 +45030,7 @@
         <a:srgbClr val="FFFFFF"/>
       </a:lt1>
       <a:dk2>
-        <a:srgbClr val="12171C"/>
+        <a:srgbClr val="00144A"/>
       </a:dk2>
       <a:lt2>
         <a:srgbClr val="F5F6F7"/>

</xml_diff>